<commit_message>
Weekly refresh: Nike 2026-10-05
</commit_message>
<xml_diff>
--- a/examples/nike/latest/NKE_pitch_deck.pptx
+++ b/examples/nike/latest/NKE_pitch_deck.pptx
@@ -2030,25 +2030,25 @@
                 <c:formatCode>General</c:formatCode>
                 <c:ptCount val="7"/>
                 <c:pt idx="0">
-                  <c:v>1.2225271579290975</c:v>
+                  <c:v>1.2275078423800179</c:v>
                 </c:pt>
                 <c:pt idx="1">
-                  <c:v>1.072011235665173</c:v>
+                  <c:v>1.0683020141241129</c:v>
                 </c:pt>
                 <c:pt idx="2">
-                  <c:v>1.0595411250265805</c:v>
+                  <c:v>1.059459694012822</c:v>
                 </c:pt>
                 <c:pt idx="3">
-                  <c:v>0.8933299195713961</c:v>
+                  <c:v>0.8913555679150604</c:v>
                 </c:pt>
                 <c:pt idx="4">
-                  <c:v>0.8171305389068616</c:v>
+                  <c:v>0.8197816724066946</c:v>
                 </c:pt>
                 <c:pt idx="5">
-                  <c:v>0.7529388997761925</c:v>
+                  <c:v>0.7567163781554276</c:v>
                 </c:pt>
                 <c:pt idx="6">
-                  <c:v>0.724301248654706</c:v>
+                  <c:v>0.7271019367642516</c:v>
                 </c:pt>
               </c:numCache>
             </c:numRef>
@@ -5477,7 +5477,7 @@
                 </a:solidFill>
                 <a:latin typeface="Cambria"/>
               </a:rPr>
-              <a:t>$32.81</a:t>
+              <a:t>$32.56</a:t>
             </a:r>
           </a:p>
         </p:txBody>
@@ -5593,7 +5593,7 @@
                 </a:solidFill>
                 <a:latin typeface="Cambria"/>
               </a:rPr>
-              <a:t>$33.87</a:t>
+              <a:t>$33.12</a:t>
             </a:r>
           </a:p>
         </p:txBody>
@@ -5709,7 +5709,7 @@
                 </a:solidFill>
                 <a:latin typeface="Cambria"/>
               </a:rPr>
-              <a:t>-3.1%</a:t>
+              <a:t>-1.7%</a:t>
             </a:r>
           </a:p>
         </p:txBody>
@@ -6121,7 +6121,7 @@
                           </a:solidFill>
                           <a:latin typeface="Calibri"/>
                         </a:rPr>
-                        <a:t>$42.04</a:t>
+                        <a:t>$42.03</a:t>
                       </a:r>
                     </a:p>
                   </a:txBody>
@@ -6144,7 +6144,7 @@
                           </a:solidFill>
                           <a:latin typeface="Calibri"/>
                         </a:rPr>
-                        <a:t>$43.66</a:t>
+                        <a:t>$43.65</a:t>
                       </a:r>
                     </a:p>
                   </a:txBody>
@@ -6238,7 +6238,7 @@
                           </a:solidFill>
                           <a:latin typeface="Calibri"/>
                         </a:rPr>
-                        <a:t>$37.31</a:t>
+                        <a:t>$37.30</a:t>
                       </a:r>
                     </a:p>
                   </a:txBody>
@@ -6267,7 +6267,7 @@
                   </a:txBody>
                   <a:tcPr marL="73152" marR="73152" marT="27432" marB="27432" anchor="ctr">
                     <a:solidFill>
-                      <a:srgbClr val="FFFFFF"/>
+                      <a:srgbClr val="D7EFE2"/>
                     </a:solidFill>
                   </a:tcPr>
                 </a:tc>
@@ -6658,13 +6658,13 @@
                           </a:solidFill>
                           <a:latin typeface="Calibri"/>
                         </a:rPr>
-                        <a:t>$30.04</a:t>
-                      </a:r>
-                    </a:p>
-                  </a:txBody>
-                  <a:tcPr marL="73152" marR="73152" marT="27432" marB="27432" anchor="ctr">
-                    <a:solidFill>
-                      <a:srgbClr val="F8D9D5"/>
+                        <a:t>$30.03</a:t>
+                      </a:r>
+                    </a:p>
+                  </a:txBody>
+                  <a:tcPr marL="73152" marR="73152" marT="27432" marB="27432" anchor="ctr">
+                    <a:solidFill>
+                      <a:srgbClr val="FFFFFF"/>
                     </a:solidFill>
                   </a:tcPr>
                 </a:tc>
@@ -6727,7 +6727,7 @@
                           </a:solidFill>
                           <a:latin typeface="Calibri"/>
                         </a:rPr>
-                        <a:t>$32.49</a:t>
+                        <a:t>$32.48</a:t>
                       </a:r>
                     </a:p>
                   </a:txBody>
@@ -6772,7 +6772,7 @@
                 </a:solidFill>
                 <a:latin typeface="Calibri"/>
               </a:rPr>
-              <a:t>Green: ≥15% above the current price ($33.87). Red: ≥10% below. Orange: base case.</a:t>
+              <a:t>Green: ≥15% above the current price ($33.12). Red: ≥10% below. Orange: base case.</a:t>
             </a:r>
           </a:p>
         </p:txBody>
@@ -6875,7 +6875,7 @@
                           </a:solidFill>
                           <a:latin typeface="Calibri"/>
                         </a:rPr>
-                        <a:t>6.7x</a:t>
+                        <a:t>6.6x</a:t>
                       </a:r>
                     </a:p>
                   </a:txBody>
@@ -6898,7 +6898,7 @@
                           </a:solidFill>
                           <a:latin typeface="Calibri"/>
                         </a:rPr>
-                        <a:t>7.7x</a:t>
+                        <a:t>7.6x</a:t>
                       </a:r>
                     </a:p>
                   </a:txBody>
@@ -6921,7 +6921,7 @@
                           </a:solidFill>
                           <a:latin typeface="Calibri"/>
                         </a:rPr>
-                        <a:t>8.7x</a:t>
+                        <a:t>8.6x</a:t>
                       </a:r>
                     </a:p>
                   </a:txBody>
@@ -6944,7 +6944,7 @@
                           </a:solidFill>
                           <a:latin typeface="Calibri"/>
                         </a:rPr>
-                        <a:t>9.7x</a:t>
+                        <a:t>9.6x</a:t>
                       </a:r>
                     </a:p>
                   </a:txBody>
@@ -6967,7 +6967,7 @@
                           </a:solidFill>
                           <a:latin typeface="Calibri"/>
                         </a:rPr>
-                        <a:t>10.7x</a:t>
+                        <a:t>10.6x</a:t>
                       </a:r>
                     </a:p>
                   </a:txBody>
@@ -7015,7 +7015,7 @@
                           </a:solidFill>
                           <a:latin typeface="Calibri"/>
                         </a:rPr>
-                        <a:t>$28.46</a:t>
+                        <a:t>$27.96</a:t>
                       </a:r>
                     </a:p>
                   </a:txBody>
@@ -7038,7 +7038,7 @@
                           </a:solidFill>
                           <a:latin typeface="Calibri"/>
                         </a:rPr>
-                        <a:t>$31.40</a:t>
+                        <a:t>$30.90</a:t>
                       </a:r>
                     </a:p>
                   </a:txBody>
@@ -7061,7 +7061,7 @@
                           </a:solidFill>
                           <a:latin typeface="Calibri"/>
                         </a:rPr>
-                        <a:t>$34.35</a:t>
+                        <a:t>$33.85</a:t>
                       </a:r>
                     </a:p>
                   </a:txBody>
@@ -7084,7 +7084,7 @@
                           </a:solidFill>
                           <a:latin typeface="Calibri"/>
                         </a:rPr>
-                        <a:t>$37.29</a:t>
+                        <a:t>$36.79</a:t>
                       </a:r>
                     </a:p>
                   </a:txBody>
@@ -7107,7 +7107,7 @@
                           </a:solidFill>
                           <a:latin typeface="Calibri"/>
                         </a:rPr>
-                        <a:t>$40.24</a:t>
+                        <a:t>$39.74</a:t>
                       </a:r>
                     </a:p>
                   </a:txBody>
@@ -7155,7 +7155,7 @@
                           </a:solidFill>
                           <a:latin typeface="Calibri"/>
                         </a:rPr>
-                        <a:t>$27.90</a:t>
+                        <a:t>$27.42</a:t>
                       </a:r>
                     </a:p>
                   </a:txBody>
@@ -7178,7 +7178,7 @@
                           </a:solidFill>
                           <a:latin typeface="Calibri"/>
                         </a:rPr>
-                        <a:t>$30.78</a:t>
+                        <a:t>$30.29</a:t>
                       </a:r>
                     </a:p>
                   </a:txBody>
@@ -7201,7 +7201,7 @@
                           </a:solidFill>
                           <a:latin typeface="Calibri"/>
                         </a:rPr>
-                        <a:t>$33.66</a:t>
+                        <a:t>$33.17</a:t>
                       </a:r>
                     </a:p>
                   </a:txBody>
@@ -7224,7 +7224,7 @@
                           </a:solidFill>
                           <a:latin typeface="Calibri"/>
                         </a:rPr>
-                        <a:t>$36.54</a:t>
+                        <a:t>$36.05</a:t>
                       </a:r>
                     </a:p>
                   </a:txBody>
@@ -7247,7 +7247,7 @@
                           </a:solidFill>
                           <a:latin typeface="Calibri"/>
                         </a:rPr>
-                        <a:t>$39.41</a:t>
+                        <a:t>$38.93</a:t>
                       </a:r>
                     </a:p>
                   </a:txBody>
@@ -7295,7 +7295,7 @@
                           </a:solidFill>
                           <a:latin typeface="Calibri"/>
                         </a:rPr>
-                        <a:t>$27.36</a:t>
+                        <a:t>$26.89</a:t>
                       </a:r>
                     </a:p>
                   </a:txBody>
@@ -7318,7 +7318,7 @@
                           </a:solidFill>
                           <a:latin typeface="Calibri"/>
                         </a:rPr>
-                        <a:t>$30.18</a:t>
+                        <a:t>$29.70</a:t>
                       </a:r>
                     </a:p>
                   </a:txBody>
@@ -7341,7 +7341,7 @@
                           </a:solidFill>
                           <a:latin typeface="Calibri"/>
                         </a:rPr>
-                        <a:t>$32.99</a:t>
+                        <a:t>$32.51</a:t>
                       </a:r>
                     </a:p>
                   </a:txBody>
@@ -7364,7 +7364,7 @@
                           </a:solidFill>
                           <a:latin typeface="Calibri"/>
                         </a:rPr>
-                        <a:t>$35.80</a:t>
+                        <a:t>$35.33</a:t>
                       </a:r>
                     </a:p>
                   </a:txBody>
@@ -7387,7 +7387,7 @@
                           </a:solidFill>
                           <a:latin typeface="Calibri"/>
                         </a:rPr>
-                        <a:t>$38.62</a:t>
+                        <a:t>$38.14</a:t>
                       </a:r>
                     </a:p>
                   </a:txBody>
@@ -7435,7 +7435,7 @@
                           </a:solidFill>
                           <a:latin typeface="Calibri"/>
                         </a:rPr>
-                        <a:t>$26.84</a:t>
+                        <a:t>$26.38</a:t>
                       </a:r>
                     </a:p>
                   </a:txBody>
@@ -7458,7 +7458,7 @@
                           </a:solidFill>
                           <a:latin typeface="Calibri"/>
                         </a:rPr>
-                        <a:t>$29.59</a:t>
+                        <a:t>$29.13</a:t>
                       </a:r>
                     </a:p>
                   </a:txBody>
@@ -7481,7 +7481,7 @@
                           </a:solidFill>
                           <a:latin typeface="Calibri"/>
                         </a:rPr>
-                        <a:t>$32.34</a:t>
+                        <a:t>$31.87</a:t>
                       </a:r>
                     </a:p>
                   </a:txBody>
@@ -7504,7 +7504,7 @@
                           </a:solidFill>
                           <a:latin typeface="Calibri"/>
                         </a:rPr>
-                        <a:t>$35.09</a:t>
+                        <a:t>$34.62</a:t>
                       </a:r>
                     </a:p>
                   </a:txBody>
@@ -7527,7 +7527,7 @@
                           </a:solidFill>
                           <a:latin typeface="Calibri"/>
                         </a:rPr>
-                        <a:t>$37.84</a:t>
+                        <a:t>$37.37</a:t>
                       </a:r>
                     </a:p>
                   </a:txBody>
@@ -7575,7 +7575,7 @@
                           </a:solidFill>
                           <a:latin typeface="Calibri"/>
                         </a:rPr>
-                        <a:t>$26.33</a:t>
+                        <a:t>$25.88</a:t>
                       </a:r>
                     </a:p>
                   </a:txBody>
@@ -7598,7 +7598,7 @@
                           </a:solidFill>
                           <a:latin typeface="Calibri"/>
                         </a:rPr>
-                        <a:t>$29.02</a:t>
+                        <a:t>$28.56</a:t>
                       </a:r>
                     </a:p>
                   </a:txBody>
@@ -7621,7 +7621,7 @@
                           </a:solidFill>
                           <a:latin typeface="Calibri"/>
                         </a:rPr>
-                        <a:t>$31.70</a:t>
+                        <a:t>$31.25</a:t>
                       </a:r>
                     </a:p>
                   </a:txBody>
@@ -7644,7 +7644,7 @@
                           </a:solidFill>
                           <a:latin typeface="Calibri"/>
                         </a:rPr>
-                        <a:t>$34.39</a:t>
+                        <a:t>$33.94</a:t>
                       </a:r>
                     </a:p>
                   </a:txBody>
@@ -7667,7 +7667,7 @@
                           </a:solidFill>
                           <a:latin typeface="Calibri"/>
                         </a:rPr>
-                        <a:t>$37.08</a:t>
+                        <a:t>$36.63</a:t>
                       </a:r>
                     </a:p>
                   </a:txBody>
@@ -7835,7 +7835,7 @@
                 </a:solidFill>
                 <a:latin typeface="Cambria"/>
               </a:rPr>
-              <a:t>Trading comps: NKE trades at 11.0x EV/EBITDA, a 25% premium to the peer median of 8.7x</a:t>
+              <a:t>Trading comps: NKE trades at 10.7x EV/EBITDA, a 25% premium to the peer median of 8.6x</a:t>
             </a:r>
           </a:p>
         </p:txBody>
@@ -8183,7 +8183,7 @@
                           </a:solidFill>
                           <a:latin typeface="Calibri"/>
                         </a:rPr>
-                        <a:t>10.5x</a:t>
+                        <a:t>10.6x</a:t>
                       </a:r>
                     </a:p>
                   </a:txBody>
@@ -8229,7 +8229,7 @@
                           </a:solidFill>
                           <a:latin typeface="Calibri"/>
                         </a:rPr>
-                        <a:t>10.2%</a:t>
+                        <a:t>10.1%</a:t>
                       </a:r>
                     </a:p>
                   </a:txBody>
@@ -8277,7 +8277,7 @@
                           </a:solidFill>
                           <a:latin typeface="Calibri"/>
                         </a:rPr>
-                        <a:t>$10.0bn</a:t>
+                        <a:t>$9.7bn</a:t>
                       </a:r>
                     </a:p>
                   </a:txBody>
@@ -8300,7 +8300,7 @@
                           </a:solidFill>
                           <a:latin typeface="Calibri"/>
                         </a:rPr>
-                        <a:t>$8.6bn</a:t>
+                        <a:t>$8.3bn</a:t>
                       </a:r>
                     </a:p>
                   </a:txBody>
@@ -8323,7 +8323,7 @@
                           </a:solidFill>
                           <a:latin typeface="Calibri"/>
                         </a:rPr>
-                        <a:t>0.8x</a:t>
+                        <a:t>0.7x</a:t>
                       </a:r>
                     </a:p>
                   </a:txBody>
@@ -8346,7 +8346,7 @@
                           </a:solidFill>
                           <a:latin typeface="Calibri"/>
                         </a:rPr>
-                        <a:t>3.2x</a:t>
+                        <a:t>3.1x</a:t>
                       </a:r>
                     </a:p>
                   </a:txBody>
@@ -8369,7 +8369,7 @@
                           </a:solidFill>
                           <a:latin typeface="Calibri"/>
                         </a:rPr>
-                        <a:t>6.3x</a:t>
+                        <a:t>6.1x</a:t>
                       </a:r>
                     </a:p>
                   </a:txBody>
@@ -8415,7 +8415,7 @@
                           </a:solidFill>
                           <a:latin typeface="Calibri"/>
                         </a:rPr>
-                        <a:t>9.2%</a:t>
+                        <a:t>9.5%</a:t>
                       </a:r>
                     </a:p>
                   </a:txBody>
@@ -8532,7 +8532,7 @@
                           </a:solidFill>
                           <a:latin typeface="Calibri"/>
                         </a:rPr>
-                        <a:t>29.8x</a:t>
+                        <a:t>29.9x</a:t>
                       </a:r>
                     </a:p>
                   </a:txBody>
@@ -8649,7 +8649,7 @@
                           </a:solidFill>
                           <a:latin typeface="Calibri"/>
                         </a:rPr>
-                        <a:t>$5.6bn</a:t>
+                        <a:t>$5.5bn</a:t>
                       </a:r>
                     </a:p>
                   </a:txBody>
@@ -8672,7 +8672,7 @@
                           </a:solidFill>
                           <a:latin typeface="Calibri"/>
                         </a:rPr>
-                        <a:t>$8.3bn</a:t>
+                        <a:t>$8.2bn</a:t>
                       </a:r>
                     </a:p>
                   </a:txBody>
@@ -8718,7 +8718,7 @@
                           </a:solidFill>
                           <a:latin typeface="Calibri"/>
                         </a:rPr>
-                        <a:t>9.7x</a:t>
+                        <a:t>9.6x</a:t>
                       </a:r>
                     </a:p>
                   </a:txBody>
@@ -8741,7 +8741,7 @@
                           </a:solidFill>
                           <a:latin typeface="Calibri"/>
                         </a:rPr>
-                        <a:t>22.0x</a:t>
+                        <a:t>21.7x</a:t>
                       </a:r>
                     </a:p>
                   </a:txBody>
@@ -8787,7 +8787,7 @@
                           </a:solidFill>
                           <a:latin typeface="Calibri"/>
                         </a:rPr>
-                        <a:t>9.9%</a:t>
+                        <a:t>10.1%</a:t>
                       </a:r>
                     </a:p>
                   </a:txBody>
@@ -8904,7 +8904,7 @@
                           </a:solidFill>
                           <a:latin typeface="Calibri"/>
                         </a:rPr>
-                        <a:t>8.7x</a:t>
+                        <a:t>8.6x</a:t>
                       </a:r>
                     </a:p>
                   </a:txBody>
@@ -8927,7 +8927,7 @@
                           </a:solidFill>
                           <a:latin typeface="Calibri"/>
                         </a:rPr>
-                        <a:t>16.5x</a:t>
+                        <a:t>16.3x</a:t>
                       </a:r>
                     </a:p>
                   </a:txBody>
@@ -8973,7 +8973,7 @@
                           </a:solidFill>
                           <a:latin typeface="Calibri"/>
                         </a:rPr>
-                        <a:t>7.4%</a:t>
+                        <a:t>7.5%</a:t>
                       </a:r>
                     </a:p>
                   </a:txBody>
@@ -9159,7 +9159,7 @@
                           </a:solidFill>
                           <a:latin typeface="Calibri"/>
                         </a:rPr>
-                        <a:t>-8.0%</a:t>
+                        <a:t>-8.2%</a:t>
                       </a:r>
                     </a:p>
                   </a:txBody>
@@ -9207,7 +9207,7 @@
                           </a:solidFill>
                           <a:latin typeface="Calibri"/>
                         </a:rPr>
-                        <a:t>$50.3bn</a:t>
+                        <a:t>$49.1bn</a:t>
                       </a:r>
                     </a:p>
                   </a:txBody>
@@ -9230,7 +9230,7 @@
                           </a:solidFill>
                           <a:latin typeface="Calibri"/>
                         </a:rPr>
-                        <a:t>$49.8bn</a:t>
+                        <a:t>$48.7bn</a:t>
                       </a:r>
                     </a:p>
                   </a:txBody>
@@ -9253,7 +9253,7 @@
                           </a:solidFill>
                           <a:latin typeface="Calibri"/>
                         </a:rPr>
-                        <a:t>1.1x</a:t>
+                        <a:t>1.0x</a:t>
                       </a:r>
                     </a:p>
                   </a:txBody>
@@ -9276,7 +9276,7 @@
                           </a:solidFill>
                           <a:latin typeface="Calibri"/>
                         </a:rPr>
-                        <a:t>11.0x</a:t>
+                        <a:t>10.7x</a:t>
                       </a:r>
                     </a:p>
                   </a:txBody>
@@ -9299,7 +9299,7 @@
                           </a:solidFill>
                           <a:latin typeface="Calibri"/>
                         </a:rPr>
-                        <a:t>16.2x</a:t>
+                        <a:t>15.8x</a:t>
                       </a:r>
                     </a:p>
                   </a:txBody>
@@ -9345,7 +9345,7 @@
                           </a:solidFill>
                           <a:latin typeface="Calibri"/>
                         </a:rPr>
-                        <a:t>4.3%</a:t>
+                        <a:t>4.4%</a:t>
                       </a:r>
                     </a:p>
                   </a:txBody>
@@ -9462,7 +9462,7 @@
                           </a:solidFill>
                           <a:latin typeface="Calibri"/>
                         </a:rPr>
-                        <a:t>8.7x</a:t>
+                        <a:t>8.6x</a:t>
                       </a:r>
                     </a:p>
                   </a:txBody>
@@ -9485,7 +9485,7 @@
                           </a:solidFill>
                           <a:latin typeface="Calibri"/>
                         </a:rPr>
-                        <a:t>13.5x</a:t>
+                        <a:t>13.4x</a:t>
                       </a:r>
                     </a:p>
                   </a:txBody>
@@ -9531,7 +9531,7 @@
                           </a:solidFill>
                           <a:latin typeface="Calibri"/>
                         </a:rPr>
-                        <a:t>9.6%</a:t>
+                        <a:t>9.8%</a:t>
                       </a:r>
                     </a:p>
                   </a:txBody>
@@ -9585,7 +9585,7 @@
                 </a:solidFill>
                 <a:latin typeface="Calibri"/>
               </a:rPr>
-              <a:t>EV/EBITDA: $27.09 (range $21.34–$30.04) · P/E: $28.36 (range $19.86–$37.51)</a:t>
+              <a:t>EV/EBITDA: $26.57 (range $21.41–$29.74) · P/E: $28.12 (range $19.81–$36.94)</a:t>
             </a:r>
           </a:p>
         </p:txBody>
@@ -9743,7 +9743,7 @@
                 </a:solidFill>
                 <a:latin typeface="Cambria"/>
               </a:rPr>
-              <a:t>Valuation range: methods point to $20–$72; price target $32.81</a:t>
+              <a:t>Valuation range: methods point to $20–$71; price target $32.56</a:t>
             </a:r>
           </a:p>
         </p:txBody>
@@ -9861,7 +9861,7 @@
         </p:nvSpPr>
         <p:spPr>
           <a:xfrm>
-            <a:off x="8028432" y="5504688"/>
+            <a:off x="8028431" y="5504688"/>
             <a:ext cx="914400" cy="274320"/>
           </a:xfrm>
           <a:prstGeom prst="rect">
@@ -9918,7 +9918,7 @@
                 </a:solidFill>
                 <a:latin typeface="Calibri"/>
               </a:rPr>
-              <a:t>$64</a:t>
+              <a:t>$63</a:t>
             </a:r>
           </a:p>
         </p:txBody>
@@ -9953,7 +9953,7 @@
                 </a:solidFill>
                 <a:latin typeface="Calibri"/>
               </a:rPr>
-              <a:t>$76</a:t>
+              <a:t>$75</a:t>
             </a:r>
           </a:p>
         </p:txBody>
@@ -10001,8 +10001,8 @@
         </p:nvSpPr>
         <p:spPr>
           <a:xfrm>
-            <a:off x="6185205" y="2167128"/>
-            <a:ext cx="4708428" cy="347472"/>
+            <a:off x="6122418" y="2167128"/>
+            <a:ext cx="4770093" cy="347472"/>
           </a:xfrm>
           <a:prstGeom prst="rect">
             <a:avLst/>
@@ -10045,7 +10045,7 @@
         </p:nvSpPr>
         <p:spPr>
           <a:xfrm>
-            <a:off x="5316525" y="2212848"/>
+            <a:off x="5253738" y="2212848"/>
             <a:ext cx="822960" cy="274320"/>
           </a:xfrm>
           <a:prstGeom prst="rect">
@@ -10067,7 +10067,7 @@
                 </a:solidFill>
                 <a:latin typeface="Calibri"/>
               </a:rPr>
-              <a:t>$34</a:t>
+              <a:t>$33</a:t>
             </a:r>
           </a:p>
         </p:txBody>
@@ -10080,7 +10080,7 @@
         </p:nvSpPr>
         <p:spPr>
           <a:xfrm>
-            <a:off x="10939354" y="2212848"/>
+            <a:off x="10938231" y="2212848"/>
             <a:ext cx="822960" cy="274320"/>
           </a:xfrm>
           <a:prstGeom prst="rect">
@@ -10102,7 +10102,7 @@
                 </a:solidFill>
                 <a:latin typeface="Calibri"/>
               </a:rPr>
-              <a:t>$72</a:t>
+              <a:t>$71</a:t>
             </a:r>
           </a:p>
         </p:txBody>
@@ -10137,7 +10137,7 @@
                 </a:solidFill>
                 <a:latin typeface="Calibri"/>
               </a:rPr>
-              <a:t>Trading comps: EV/EBITDA 6.9x–9.7x</a:t>
+              <a:t>Trading comps: EV/EBITDA 6.9x–9.6x</a:t>
             </a:r>
           </a:p>
         </p:txBody>
@@ -10150,8 +10150,8 @@
         </p:nvSpPr>
         <p:spPr>
           <a:xfrm>
-            <a:off x="4634978" y="2734056"/>
-            <a:ext cx="1076390" cy="347472"/>
+            <a:off x="4655117" y="2734056"/>
+            <a:ext cx="1044118" cy="347472"/>
           </a:xfrm>
           <a:prstGeom prst="rect">
             <a:avLst/>
@@ -10194,7 +10194,7 @@
         </p:nvSpPr>
         <p:spPr>
           <a:xfrm>
-            <a:off x="3766298" y="2779776"/>
+            <a:off x="3786437" y="2779776"/>
             <a:ext cx="822960" cy="274320"/>
           </a:xfrm>
           <a:prstGeom prst="rect">
@@ -10229,7 +10229,7 @@
         </p:nvSpPr>
         <p:spPr>
           <a:xfrm>
-            <a:off x="5757088" y="2779776"/>
+            <a:off x="5744955" y="2779776"/>
             <a:ext cx="822960" cy="274320"/>
           </a:xfrm>
           <a:prstGeom prst="rect">
@@ -10286,7 +10286,7 @@
                 </a:solidFill>
                 <a:latin typeface="Calibri"/>
               </a:rPr>
-              <a:t>Trading comps: P/E 9.5x–17.9x</a:t>
+              <a:t>Trading comps: P/E 9.5x–17.6x</a:t>
             </a:r>
           </a:p>
         </p:txBody>
@@ -10299,8 +10299,8 @@
         </p:nvSpPr>
         <p:spPr>
           <a:xfrm>
-            <a:off x="4451919" y="3300984"/>
-            <a:ext cx="2183706" cy="347472"/>
+            <a:off x="4454539" y="3300984"/>
+            <a:ext cx="2147738" cy="347472"/>
           </a:xfrm>
           <a:prstGeom prst="rect">
             <a:avLst/>
@@ -10343,7 +10343,7 @@
         </p:nvSpPr>
         <p:spPr>
           <a:xfrm>
-            <a:off x="3583239" y="3346704"/>
+            <a:off x="3585859" y="3346704"/>
             <a:ext cx="822960" cy="274320"/>
           </a:xfrm>
           <a:prstGeom prst="rect">
@@ -10378,7 +10378,7 @@
         </p:nvSpPr>
         <p:spPr>
           <a:xfrm>
-            <a:off x="6681346" y="3346704"/>
+            <a:off x="6647998" y="3346704"/>
             <a:ext cx="822960" cy="274320"/>
           </a:xfrm>
           <a:prstGeom prst="rect">
@@ -10400,7 +10400,7 @@
                 </a:solidFill>
                 <a:latin typeface="Calibri"/>
               </a:rPr>
-              <a:t>$38</a:t>
+              <a:t>$37</a:t>
             </a:r>
           </a:p>
         </p:txBody>
@@ -10448,8 +10448,8 @@
         </p:nvSpPr>
         <p:spPr>
           <a:xfrm>
-            <a:off x="5969969" y="3867911"/>
-            <a:ext cx="958596" cy="347472"/>
+            <a:off x="5998705" y="3867911"/>
+            <a:ext cx="971133" cy="347472"/>
           </a:xfrm>
           <a:prstGeom prst="rect">
             <a:avLst/>
@@ -10492,7 +10492,7 @@
         </p:nvSpPr>
         <p:spPr>
           <a:xfrm>
-            <a:off x="5101289" y="3913631"/>
+            <a:off x="5130025" y="3913631"/>
             <a:ext cx="822960" cy="274320"/>
           </a:xfrm>
           <a:prstGeom prst="rect">
@@ -10527,7 +10527,7 @@
         </p:nvSpPr>
         <p:spPr>
           <a:xfrm>
-            <a:off x="6974286" y="3913631"/>
+            <a:off x="7015558" y="3913631"/>
             <a:ext cx="822960" cy="274320"/>
           </a:xfrm>
           <a:prstGeom prst="rect">
@@ -10597,8 +10597,8 @@
         </p:nvSpPr>
         <p:spPr>
           <a:xfrm>
-            <a:off x="5655722" y="4434840"/>
-            <a:ext cx="859401" cy="347472"/>
+            <a:off x="5622334" y="4434840"/>
+            <a:ext cx="868026" cy="347472"/>
           </a:xfrm>
           <a:prstGeom prst="rect">
             <a:avLst/>
@@ -10641,7 +10641,7 @@
         </p:nvSpPr>
         <p:spPr>
           <a:xfrm>
-            <a:off x="4787042" y="4480560"/>
+            <a:off x="4753654" y="4480560"/>
             <a:ext cx="822960" cy="274320"/>
           </a:xfrm>
           <a:prstGeom prst="rect">
@@ -10663,7 +10663,7 @@
                 </a:solidFill>
                 <a:latin typeface="Calibri"/>
               </a:rPr>
-              <a:t>$30</a:t>
+              <a:t>$29</a:t>
             </a:r>
           </a:p>
         </p:txBody>
@@ -10676,7 +10676,7 @@
         </p:nvSpPr>
         <p:spPr>
           <a:xfrm>
-            <a:off x="6560843" y="4480560"/>
+            <a:off x="6536081" y="4480560"/>
             <a:ext cx="822960" cy="274320"/>
           </a:xfrm>
           <a:prstGeom prst="rect">
@@ -10698,7 +10698,7 @@
                 </a:solidFill>
                 <a:latin typeface="Calibri"/>
               </a:rPr>
-              <a:t>$37</a:t>
+              <a:t>$36</a:t>
             </a:r>
           </a:p>
         </p:txBody>
@@ -10746,8 +10746,8 @@
         </p:nvSpPr>
         <p:spPr>
           <a:xfrm>
-            <a:off x="4778950" y="5001768"/>
-            <a:ext cx="4457129" cy="347472"/>
+            <a:off x="4792027" y="5001768"/>
+            <a:ext cx="4515570" cy="347472"/>
           </a:xfrm>
           <a:prstGeom prst="rect">
             <a:avLst/>
@@ -10790,7 +10790,7 @@
         </p:nvSpPr>
         <p:spPr>
           <a:xfrm>
-            <a:off x="3910270" y="5047488"/>
+            <a:off x="3923347" y="5047488"/>
             <a:ext cx="822960" cy="274320"/>
           </a:xfrm>
           <a:prstGeom prst="rect">
@@ -10825,7 +10825,7 @@
         </p:nvSpPr>
         <p:spPr>
           <a:xfrm>
-            <a:off x="9281799" y="5047488"/>
+            <a:off x="9353318" y="5047488"/>
             <a:ext cx="822960" cy="274320"/>
           </a:xfrm>
           <a:prstGeom prst="rect">
@@ -10860,7 +10860,7 @@
         </p:nvCxnSpPr>
         <p:spPr>
           <a:xfrm>
-            <a:off x="6185205" y="1965960"/>
+            <a:off x="6122418" y="1965960"/>
             <a:ext cx="0" cy="3493008"/>
           </a:xfrm>
           <a:prstGeom prst="line">
@@ -10896,7 +10896,7 @@
         </p:nvCxnSpPr>
         <p:spPr>
           <a:xfrm>
-            <a:off x="6053497" y="1965960"/>
+            <a:off x="6052351" y="1965960"/>
             <a:ext cx="0" cy="3493008"/>
           </a:xfrm>
           <a:prstGeom prst="line">
@@ -10931,7 +10931,7 @@
         </p:nvSpPr>
         <p:spPr>
           <a:xfrm>
-            <a:off x="6258357" y="1673352"/>
+            <a:off x="6195570" y="1673352"/>
             <a:ext cx="1828800" cy="274320"/>
           </a:xfrm>
           <a:prstGeom prst="rect">
@@ -10953,7 +10953,7 @@
                 </a:solidFill>
                 <a:latin typeface="Calibri"/>
               </a:rPr>
-              <a:t>Price $33.87</a:t>
+              <a:t>Price $33.12</a:t>
             </a:r>
           </a:p>
         </p:txBody>
@@ -10966,7 +10966,7 @@
         </p:nvSpPr>
         <p:spPr>
           <a:xfrm>
-            <a:off x="4151545" y="1673352"/>
+            <a:off x="4150399" y="1673352"/>
             <a:ext cx="1828800" cy="274320"/>
           </a:xfrm>
           <a:prstGeom prst="rect">
@@ -10988,7 +10988,7 @@
                 </a:solidFill>
                 <a:latin typeface="Calibri"/>
               </a:rPr>
-              <a:t>Target $32.81</a:t>
+              <a:t>Target $32.56</a:t>
             </a:r>
           </a:p>
         </p:txBody>
@@ -11023,7 +11023,7 @@
                 </a:solidFill>
                 <a:latin typeface="Calibri"/>
               </a:rPr>
-              <a:t>Price target = 50% × DCF perpetuity ($35.57) + 25% × DCF exit multiple ($32.99) + 25% × comps EV/EBITDA ($27.09)</a:t>
+              <a:t>Price target = 50% × DCF perpetuity ($35.57) + 25% × DCF exit multiple ($32.51) + 25% × comps EV/EBITDA ($26.57)</a:t>
             </a:r>
           </a:p>
         </p:txBody>
@@ -11330,7 +11330,7 @@
                 </a:solidFill>
                 <a:latin typeface="Calibri"/>
               </a:rPr>
-              <a:t>-34% vs current price</a:t>
+              <a:t>-32% vs current price</a:t>
             </a:r>
           </a:p>
         </p:txBody>
@@ -11759,7 +11759,7 @@
                 </a:solidFill>
                 <a:latin typeface="Calibri"/>
               </a:rPr>
-              <a:t>+5% vs current price</a:t>
+              <a:t>+7% vs current price</a:t>
             </a:r>
           </a:p>
         </p:txBody>
@@ -12188,7 +12188,7 @@
                 </a:solidFill>
                 <a:latin typeface="Calibri"/>
               </a:rPr>
-              <a:t>+73% vs current price</a:t>
+              <a:t>+77% vs current price</a:t>
             </a:r>
           </a:p>
         </p:txBody>
@@ -12759,7 +12759,7 @@
                 </a:solidFill>
                 <a:latin typeface="Calibri"/>
               </a:rPr>
-              <a:t>Premium multiple (11.0x EV/EBITDA vs peers 8.7x) despite below-median growth.</a:t>
+              <a:t>Premium multiple (10.7x EV/EBITDA vs peers 8.6x) despite below-median growth.</a:t>
             </a:r>
           </a:p>
         </p:txBody>
@@ -13603,7 +13603,7 @@
                 </a:solidFill>
                 <a:latin typeface="Cambria"/>
               </a:rPr>
-              <a:t>HOLD: $32.81 price target implies 3% downside</a:t>
+              <a:t>HOLD: $32.56 price target implies 2% downside</a:t>
             </a:r>
           </a:p>
         </p:txBody>
@@ -13831,7 +13831,7 @@
                 </a:solidFill>
                 <a:latin typeface="Cambria"/>
               </a:rPr>
-              <a:t>$32.81</a:t>
+              <a:t>$32.56</a:t>
             </a:r>
           </a:p>
         </p:txBody>
@@ -13945,7 +13945,7 @@
                 </a:solidFill>
                 <a:latin typeface="Cambria"/>
               </a:rPr>
-              <a:t>-3.1%</a:t>
+              <a:t>-1.7%</a:t>
             </a:r>
           </a:p>
         </p:txBody>
@@ -14166,7 +14166,7 @@
                 </a:solidFill>
                 <a:latin typeface="Calibri"/>
               </a:rPr>
-              <a:t>Price target $32.81 vs $33.87 current: -3.1% implied return → HOLD. DCF (perpetuity growth 2.5%, WACC 9.2%): $35.57 per share; exit-multiple method (8.7x EBITDA): $32.99.</a:t>
+              <a:t>Price target $32.56 vs $33.12 current: -1.7% implied return → HOLD. DCF (perpetuity growth 2.5%, WACC 9.2%): $35.57 per share; exit-multiple method (8.6x EBITDA): $32.51.</a:t>
             </a:r>
           </a:p>
         </p:txBody>
@@ -15868,7 +15868,7 @@
                 </a:solidFill>
                 <a:latin typeface="Calibri"/>
               </a:rPr>
-              <a:t>$50.3bn</a:t>
+              <a:t>$49.1bn</a:t>
             </a:r>
           </a:p>
         </p:txBody>
@@ -15938,7 +15938,7 @@
                 </a:solidFill>
                 <a:latin typeface="Calibri"/>
               </a:rPr>
-              <a:t>$49.8bn</a:t>
+              <a:t>$48.7bn</a:t>
             </a:r>
           </a:p>
         </p:txBody>
@@ -16078,7 +16078,7 @@
                 </a:solidFill>
                 <a:latin typeface="Calibri"/>
               </a:rPr>
-              <a:t>11.0x</a:t>
+              <a:t>10.7x</a:t>
             </a:r>
           </a:p>
         </p:txBody>
@@ -16148,7 +16148,7 @@
                 </a:solidFill>
                 <a:latin typeface="Calibri"/>
               </a:rPr>
-              <a:t>16.2x</a:t>
+              <a:t>15.8x</a:t>
             </a:r>
           </a:p>
         </p:txBody>
@@ -16218,7 +16218,7 @@
                 </a:solidFill>
                 <a:latin typeface="Calibri"/>
               </a:rPr>
-              <a:t>$33.87 – $71.93</a:t>
+              <a:t>$33.12 – $71.17</a:t>
             </a:r>
           </a:p>
         </p:txBody>
@@ -19884,7 +19884,7 @@
                           </a:solidFill>
                           <a:latin typeface="Calibri"/>
                         </a:rPr>
-                        <a:t>40,332</a:t>
+                        <a:t>40,328</a:t>
                       </a:r>
                     </a:p>
                   </a:txBody>
@@ -19932,7 +19932,7 @@
                           </a:solidFill>
                           <a:latin typeface="Calibri"/>
                         </a:rPr>
-                        <a:t>52,319</a:t>
+                        <a:t>52,315</a:t>
                       </a:r>
                     </a:p>
                   </a:txBody>
@@ -20028,7 +20028,7 @@
                           </a:solidFill>
                           <a:latin typeface="Calibri"/>
                         </a:rPr>
-                        <a:t>52,794</a:t>
+                        <a:t>52,790</a:t>
                       </a:r>
                     </a:p>
                   </a:txBody>
@@ -20268,7 +20268,7 @@
                           </a:solidFill>
                           <a:latin typeface="Calibri"/>
                         </a:rPr>
-                        <a:t>$32.99 at 8.7x</a:t>
+                        <a:t>$32.51 at 8.6x</a:t>
                       </a:r>
                     </a:p>
                   </a:txBody>

</xml_diff>

<commit_message>
Weekly refresh: Nike 2026-10-12
</commit_message>
<xml_diff>
--- a/examples/nike/latest/NKE_pitch_deck.pptx
+++ b/examples/nike/latest/NKE_pitch_deck.pptx
@@ -2003,10 +2003,10 @@
                   <c:v>DECK</c:v>
                 </c:pt>
                 <c:pt idx="1">
-                  <c:v>LULU</c:v>
+                  <c:v>VFC</c:v>
                 </c:pt>
                 <c:pt idx="2">
-                  <c:v>VFC</c:v>
+                  <c:v>LULU</c:v>
                 </c:pt>
                 <c:pt idx="3">
                   <c:v>NKE</c:v>
@@ -2030,25 +2030,25 @@
                 <c:formatCode>General</c:formatCode>
                 <c:ptCount val="7"/>
                 <c:pt idx="0">
-                  <c:v>1.2275078423800179</c:v>
+                  <c:v>1.231838653419015</c:v>
                 </c:pt>
                 <c:pt idx="1">
-                  <c:v>1.0683020141241129</c:v>
+                  <c:v>1.1004149633224605</c:v>
                 </c:pt>
                 <c:pt idx="2">
-                  <c:v>1.059459694012822</c:v>
+                  <c:v>1.0638998589787254</c:v>
                 </c:pt>
                 <c:pt idx="3">
-                  <c:v>0.8913555679150604</c:v>
+                  <c:v>0.8979052562253673</c:v>
                 </c:pt>
                 <c:pt idx="4">
-                  <c:v>0.8197816724066946</c:v>
+                  <c:v>0.8263328092791826</c:v>
                 </c:pt>
                 <c:pt idx="5">
-                  <c:v>0.7567163781554276</c:v>
+                  <c:v>0.7520296767954916</c:v>
                 </c:pt>
                 <c:pt idx="6">
-                  <c:v>0.7271019367642516</c:v>
+                  <c:v>0.7224406134122813</c:v>
                 </c:pt>
               </c:numCache>
             </c:numRef>
@@ -5477,7 +5477,7 @@
                 </a:solidFill>
                 <a:latin typeface="Cambria"/>
               </a:rPr>
-              <a:t>$32.56</a:t>
+              <a:t>$32.49</a:t>
             </a:r>
           </a:p>
         </p:txBody>
@@ -5593,7 +5593,7 @@
                 </a:solidFill>
                 <a:latin typeface="Cambria"/>
               </a:rPr>
-              <a:t>$33.12</a:t>
+              <a:t>$35.06</a:t>
             </a:r>
           </a:p>
         </p:txBody>
@@ -5709,7 +5709,7 @@
                 </a:solidFill>
                 <a:latin typeface="Cambria"/>
               </a:rPr>
-              <a:t>-1.7%</a:t>
+              <a:t>-7.3%</a:t>
             </a:r>
           </a:p>
         </p:txBody>
@@ -5744,7 +5744,7 @@
                 </a:solidFill>
                 <a:latin typeface="Calibri"/>
               </a:rPr>
-              <a:t>Abhishek Raut · 2026-10-05</a:t>
+              <a:t>Abhishek Raut · 2026-10-12</a:t>
             </a:r>
           </a:p>
         </p:txBody>
@@ -6052,7 +6052,7 @@
                           </a:solidFill>
                           <a:latin typeface="Calibri"/>
                         </a:rPr>
-                        <a:t>8.20%</a:t>
+                        <a:t>8.22%</a:t>
                       </a:r>
                     </a:p>
                   </a:txBody>
@@ -6075,7 +6075,30 @@
                           </a:solidFill>
                           <a:latin typeface="Calibri"/>
                         </a:rPr>
-                        <a:t>$39.19</a:t>
+                        <a:t>$39.07</a:t>
+                      </a:r>
+                    </a:p>
+                  </a:txBody>
+                  <a:tcPr marL="73152" marR="73152" marT="27432" marB="27432" anchor="ctr">
+                    <a:solidFill>
+                      <a:srgbClr val="FFFFFF"/>
+                    </a:solidFill>
+                  </a:tcPr>
+                </a:tc>
+                <a:tc>
+                  <a:txBody>
+                    <a:bodyPr wrap="square"/>
+                    <a:lstStyle/>
+                    <a:p>
+                      <a:pPr algn="ctr"/>
+                      <a:r>
+                        <a:rPr sz="1300" b="0">
+                          <a:solidFill>
+                            <a:srgbClr val="1F2933"/>
+                          </a:solidFill>
+                          <a:latin typeface="Calibri"/>
+                        </a:rPr>
+                        <a:t>$40.43</a:t>
                       </a:r>
                     </a:p>
                   </a:txBody>
@@ -6098,7 +6121,7 @@
                           </a:solidFill>
                           <a:latin typeface="Calibri"/>
                         </a:rPr>
-                        <a:t>$40.55</a:t>
+                        <a:t>$41.90</a:t>
                       </a:r>
                     </a:p>
                   </a:txBody>
@@ -6121,7 +6144,7 @@
                           </a:solidFill>
                           <a:latin typeface="Calibri"/>
                         </a:rPr>
-                        <a:t>$42.03</a:t>
+                        <a:t>$43.51</a:t>
                       </a:r>
                     </a:p>
                   </a:txBody>
@@ -6144,30 +6167,7 @@
                           </a:solidFill>
                           <a:latin typeface="Calibri"/>
                         </a:rPr>
-                        <a:t>$43.65</a:t>
-                      </a:r>
-                    </a:p>
-                  </a:txBody>
-                  <a:tcPr marL="73152" marR="73152" marT="27432" marB="27432" anchor="ctr">
-                    <a:solidFill>
-                      <a:srgbClr val="D7EFE2"/>
-                    </a:solidFill>
-                  </a:tcPr>
-                </a:tc>
-                <a:tc>
-                  <a:txBody>
-                    <a:bodyPr wrap="square"/>
-                    <a:lstStyle/>
-                    <a:p>
-                      <a:pPr algn="ctr"/>
-                      <a:r>
-                        <a:rPr sz="1300" b="0">
-                          <a:solidFill>
-                            <a:srgbClr val="1F2933"/>
-                          </a:solidFill>
-                          <a:latin typeface="Calibri"/>
-                        </a:rPr>
-                        <a:t>$45.43</a:t>
+                        <a:t>$45.27</a:t>
                       </a:r>
                     </a:p>
                   </a:txBody>
@@ -6192,7 +6192,7 @@
                           </a:solidFill>
                           <a:latin typeface="Calibri"/>
                         </a:rPr>
-                        <a:t>8.70%</a:t>
+                        <a:t>8.72%</a:t>
                       </a:r>
                     </a:p>
                   </a:txBody>
@@ -6215,7 +6215,7 @@
                           </a:solidFill>
                           <a:latin typeface="Calibri"/>
                         </a:rPr>
-                        <a:t>$36.16</a:t>
+                        <a:t>$36.06</a:t>
                       </a:r>
                     </a:p>
                   </a:txBody>
@@ -6238,7 +6238,7 @@
                           </a:solidFill>
                           <a:latin typeface="Calibri"/>
                         </a:rPr>
-                        <a:t>$37.30</a:t>
+                        <a:t>$37.20</a:t>
                       </a:r>
                     </a:p>
                   </a:txBody>
@@ -6261,13 +6261,13 @@
                           </a:solidFill>
                           <a:latin typeface="Calibri"/>
                         </a:rPr>
-                        <a:t>$38.54</a:t>
-                      </a:r>
-                    </a:p>
-                  </a:txBody>
-                  <a:tcPr marL="73152" marR="73152" marT="27432" marB="27432" anchor="ctr">
-                    <a:solidFill>
-                      <a:srgbClr val="D7EFE2"/>
+                        <a:t>$38.43</a:t>
+                      </a:r>
+                    </a:p>
+                  </a:txBody>
+                  <a:tcPr marL="73152" marR="73152" marT="27432" marB="27432" anchor="ctr">
+                    <a:solidFill>
+                      <a:srgbClr val="FFFFFF"/>
                     </a:solidFill>
                   </a:tcPr>
                 </a:tc>
@@ -6284,13 +6284,13 @@
                           </a:solidFill>
                           <a:latin typeface="Calibri"/>
                         </a:rPr>
-                        <a:t>$39.88</a:t>
-                      </a:r>
-                    </a:p>
-                  </a:txBody>
-                  <a:tcPr marL="73152" marR="73152" marT="27432" marB="27432" anchor="ctr">
-                    <a:solidFill>
-                      <a:srgbClr val="D7EFE2"/>
+                        <a:t>$39.76</a:t>
+                      </a:r>
+                    </a:p>
+                  </a:txBody>
+                  <a:tcPr marL="73152" marR="73152" marT="27432" marB="27432" anchor="ctr">
+                    <a:solidFill>
+                      <a:srgbClr val="FFFFFF"/>
                     </a:solidFill>
                   </a:tcPr>
                 </a:tc>
@@ -6307,7 +6307,7 @@
                           </a:solidFill>
                           <a:latin typeface="Calibri"/>
                         </a:rPr>
-                        <a:t>$41.33</a:t>
+                        <a:t>$41.20</a:t>
                       </a:r>
                     </a:p>
                   </a:txBody>
@@ -6332,7 +6332,7 @@
                           </a:solidFill>
                           <a:latin typeface="Calibri"/>
                         </a:rPr>
-                        <a:t>9.20%</a:t>
+                        <a:t>9.22%</a:t>
                       </a:r>
                     </a:p>
                   </a:txBody>
@@ -6355,7 +6355,7 @@
                           </a:solidFill>
                           <a:latin typeface="Calibri"/>
                         </a:rPr>
-                        <a:t>$33.56</a:t>
+                        <a:t>$33.48</a:t>
                       </a:r>
                     </a:p>
                   </a:txBody>
@@ -6378,7 +6378,7 @@
                           </a:solidFill>
                           <a:latin typeface="Calibri"/>
                         </a:rPr>
-                        <a:t>$34.53</a:t>
+                        <a:t>$34.44</a:t>
                       </a:r>
                     </a:p>
                   </a:txBody>
@@ -6401,7 +6401,7 @@
                           </a:solidFill>
                           <a:latin typeface="Calibri"/>
                         </a:rPr>
-                        <a:t>$35.57</a:t>
+                        <a:t>$35.47</a:t>
                       </a:r>
                     </a:p>
                   </a:txBody>
@@ -6424,7 +6424,7 @@
                           </a:solidFill>
                           <a:latin typeface="Calibri"/>
                         </a:rPr>
-                        <a:t>$36.69</a:t>
+                        <a:t>$36.59</a:t>
                       </a:r>
                     </a:p>
                   </a:txBody>
@@ -6447,7 +6447,7 @@
                           </a:solidFill>
                           <a:latin typeface="Calibri"/>
                         </a:rPr>
-                        <a:t>$37.90</a:t>
+                        <a:t>$37.79</a:t>
                       </a:r>
                     </a:p>
                   </a:txBody>
@@ -6472,7 +6472,7 @@
                           </a:solidFill>
                           <a:latin typeface="Calibri"/>
                         </a:rPr>
-                        <a:t>9.70%</a:t>
+                        <a:t>9.72%</a:t>
                       </a:r>
                     </a:p>
                   </a:txBody>
@@ -6495,7 +6495,30 @@
                           </a:solidFill>
                           <a:latin typeface="Calibri"/>
                         </a:rPr>
-                        <a:t>$31.30</a:t>
+                        <a:t>$31.23</a:t>
+                      </a:r>
+                    </a:p>
+                  </a:txBody>
+                  <a:tcPr marL="73152" marR="73152" marT="27432" marB="27432" anchor="ctr">
+                    <a:solidFill>
+                      <a:srgbClr val="F8D9D5"/>
+                    </a:solidFill>
+                  </a:tcPr>
+                </a:tc>
+                <a:tc>
+                  <a:txBody>
+                    <a:bodyPr wrap="square"/>
+                    <a:lstStyle/>
+                    <a:p>
+                      <a:pPr algn="ctr"/>
+                      <a:r>
+                        <a:rPr sz="1300" b="0">
+                          <a:solidFill>
+                            <a:srgbClr val="1F2933"/>
+                          </a:solidFill>
+                          <a:latin typeface="Calibri"/>
+                        </a:rPr>
+                        <a:t>$32.05</a:t>
                       </a:r>
                     </a:p>
                   </a:txBody>
@@ -6518,7 +6541,7 @@
                           </a:solidFill>
                           <a:latin typeface="Calibri"/>
                         </a:rPr>
-                        <a:t>$32.13</a:t>
+                        <a:t>$32.93</a:t>
                       </a:r>
                     </a:p>
                   </a:txBody>
@@ -6541,7 +6564,7 @@
                           </a:solidFill>
                           <a:latin typeface="Calibri"/>
                         </a:rPr>
-                        <a:t>$33.02</a:t>
+                        <a:t>$33.88</a:t>
                       </a:r>
                     </a:p>
                   </a:txBody>
@@ -6564,30 +6587,7 @@
                           </a:solidFill>
                           <a:latin typeface="Calibri"/>
                         </a:rPr>
-                        <a:t>$33.97</a:t>
-                      </a:r>
-                    </a:p>
-                  </a:txBody>
-                  <a:tcPr marL="73152" marR="73152" marT="27432" marB="27432" anchor="ctr">
-                    <a:solidFill>
-                      <a:srgbClr val="FFFFFF"/>
-                    </a:solidFill>
-                  </a:tcPr>
-                </a:tc>
-                <a:tc>
-                  <a:txBody>
-                    <a:bodyPr wrap="square"/>
-                    <a:lstStyle/>
-                    <a:p>
-                      <a:pPr algn="ctr"/>
-                      <a:r>
-                        <a:rPr sz="1300" b="0">
-                          <a:solidFill>
-                            <a:srgbClr val="1F2933"/>
-                          </a:solidFill>
-                          <a:latin typeface="Calibri"/>
-                        </a:rPr>
-                        <a:t>$34.99</a:t>
+                        <a:t>$34.90</a:t>
                       </a:r>
                     </a:p>
                   </a:txBody>
@@ -6612,7 +6612,7 @@
                           </a:solidFill>
                           <a:latin typeface="Calibri"/>
                         </a:rPr>
-                        <a:t>10.20%</a:t>
+                        <a:t>10.22%</a:t>
                       </a:r>
                     </a:p>
                   </a:txBody>
@@ -6635,7 +6635,7 @@
                           </a:solidFill>
                           <a:latin typeface="Calibri"/>
                         </a:rPr>
-                        <a:t>$29.32</a:t>
+                        <a:t>$29.25</a:t>
                       </a:r>
                     </a:p>
                   </a:txBody>
@@ -6658,13 +6658,13 @@
                           </a:solidFill>
                           <a:latin typeface="Calibri"/>
                         </a:rPr>
-                        <a:t>$30.03</a:t>
-                      </a:r>
-                    </a:p>
-                  </a:txBody>
-                  <a:tcPr marL="73152" marR="73152" marT="27432" marB="27432" anchor="ctr">
-                    <a:solidFill>
-                      <a:srgbClr val="FFFFFF"/>
+                        <a:t>$29.97</a:t>
+                      </a:r>
+                    </a:p>
+                  </a:txBody>
+                  <a:tcPr marL="73152" marR="73152" marT="27432" marB="27432" anchor="ctr">
+                    <a:solidFill>
+                      <a:srgbClr val="F8D9D5"/>
                     </a:solidFill>
                   </a:tcPr>
                 </a:tc>
@@ -6681,13 +6681,13 @@
                           </a:solidFill>
                           <a:latin typeface="Calibri"/>
                         </a:rPr>
-                        <a:t>$30.80</a:t>
-                      </a:r>
-                    </a:p>
-                  </a:txBody>
-                  <a:tcPr marL="73152" marR="73152" marT="27432" marB="27432" anchor="ctr">
-                    <a:solidFill>
-                      <a:srgbClr val="FFFFFF"/>
+                        <a:t>$30.73</a:t>
+                      </a:r>
+                    </a:p>
+                  </a:txBody>
+                  <a:tcPr marL="73152" marR="73152" marT="27432" marB="27432" anchor="ctr">
+                    <a:solidFill>
+                      <a:srgbClr val="F8D9D5"/>
                     </a:solidFill>
                   </a:tcPr>
                 </a:tc>
@@ -6704,13 +6704,13 @@
                           </a:solidFill>
                           <a:latin typeface="Calibri"/>
                         </a:rPr>
-                        <a:t>$31.61</a:t>
-                      </a:r>
-                    </a:p>
-                  </a:txBody>
-                  <a:tcPr marL="73152" marR="73152" marT="27432" marB="27432" anchor="ctr">
-                    <a:solidFill>
-                      <a:srgbClr val="FFFFFF"/>
+                        <a:t>$31.54</a:t>
+                      </a:r>
+                    </a:p>
+                  </a:txBody>
+                  <a:tcPr marL="73152" marR="73152" marT="27432" marB="27432" anchor="ctr">
+                    <a:solidFill>
+                      <a:srgbClr val="F8D9D5"/>
                     </a:solidFill>
                   </a:tcPr>
                 </a:tc>
@@ -6727,7 +6727,7 @@
                           </a:solidFill>
                           <a:latin typeface="Calibri"/>
                         </a:rPr>
-                        <a:t>$32.48</a:t>
+                        <a:t>$32.40</a:t>
                       </a:r>
                     </a:p>
                   </a:txBody>
@@ -6772,7 +6772,7 @@
                 </a:solidFill>
                 <a:latin typeface="Calibri"/>
               </a:rPr>
-              <a:t>Green: ≥15% above the current price ($33.12). Red: ≥10% below. Orange: base case.</a:t>
+              <a:t>Green: ≥15% above the current price ($35.06). Red: ≥10% below. Orange: base case.</a:t>
             </a:r>
           </a:p>
         </p:txBody>
@@ -6992,7 +6992,7 @@
                           </a:solidFill>
                           <a:latin typeface="Calibri"/>
                         </a:rPr>
-                        <a:t>8.20%</a:t>
+                        <a:t>8.22%</a:t>
                       </a:r>
                     </a:p>
                   </a:txBody>
@@ -7015,7 +7015,7 @@
                           </a:solidFill>
                           <a:latin typeface="Calibri"/>
                         </a:rPr>
-                        <a:t>$27.96</a:t>
+                        <a:t>$27.91</a:t>
                       </a:r>
                     </a:p>
                   </a:txBody>
@@ -7038,7 +7038,7 @@
                           </a:solidFill>
                           <a:latin typeface="Calibri"/>
                         </a:rPr>
-                        <a:t>$30.90</a:t>
+                        <a:t>$30.85</a:t>
                       </a:r>
                     </a:p>
                   </a:txBody>
@@ -7061,7 +7061,7 @@
                           </a:solidFill>
                           <a:latin typeface="Calibri"/>
                         </a:rPr>
-                        <a:t>$33.85</a:t>
+                        <a:t>$33.80</a:t>
                       </a:r>
                     </a:p>
                   </a:txBody>
@@ -7084,7 +7084,7 @@
                           </a:solidFill>
                           <a:latin typeface="Calibri"/>
                         </a:rPr>
-                        <a:t>$36.79</a:t>
+                        <a:t>$36.74</a:t>
                       </a:r>
                     </a:p>
                   </a:txBody>
@@ -7107,7 +7107,7 @@
                           </a:solidFill>
                           <a:latin typeface="Calibri"/>
                         </a:rPr>
-                        <a:t>$39.74</a:t>
+                        <a:t>$39.68</a:t>
                       </a:r>
                     </a:p>
                   </a:txBody>
@@ -7132,7 +7132,7 @@
                           </a:solidFill>
                           <a:latin typeface="Calibri"/>
                         </a:rPr>
-                        <a:t>8.70%</a:t>
+                        <a:t>8.72%</a:t>
                       </a:r>
                     </a:p>
                   </a:txBody>
@@ -7155,7 +7155,7 @@
                           </a:solidFill>
                           <a:latin typeface="Calibri"/>
                         </a:rPr>
-                        <a:t>$27.42</a:t>
+                        <a:t>$27.37</a:t>
                       </a:r>
                     </a:p>
                   </a:txBody>
@@ -7178,7 +7178,7 @@
                           </a:solidFill>
                           <a:latin typeface="Calibri"/>
                         </a:rPr>
-                        <a:t>$30.29</a:t>
+                        <a:t>$30.25</a:t>
                       </a:r>
                     </a:p>
                   </a:txBody>
@@ -7201,7 +7201,7 @@
                           </a:solidFill>
                           <a:latin typeface="Calibri"/>
                         </a:rPr>
-                        <a:t>$33.17</a:t>
+                        <a:t>$33.12</a:t>
                       </a:r>
                     </a:p>
                   </a:txBody>
@@ -7224,7 +7224,7 @@
                           </a:solidFill>
                           <a:latin typeface="Calibri"/>
                         </a:rPr>
-                        <a:t>$36.05</a:t>
+                        <a:t>$36.00</a:t>
                       </a:r>
                     </a:p>
                   </a:txBody>
@@ -7247,7 +7247,7 @@
                           </a:solidFill>
                           <a:latin typeface="Calibri"/>
                         </a:rPr>
-                        <a:t>$38.93</a:t>
+                        <a:t>$38.87</a:t>
                       </a:r>
                     </a:p>
                   </a:txBody>
@@ -7272,7 +7272,7 @@
                           </a:solidFill>
                           <a:latin typeface="Calibri"/>
                         </a:rPr>
-                        <a:t>9.20%</a:t>
+                        <a:t>9.22%</a:t>
                       </a:r>
                     </a:p>
                   </a:txBody>
@@ -7295,7 +7295,7 @@
                           </a:solidFill>
                           <a:latin typeface="Calibri"/>
                         </a:rPr>
-                        <a:t>$26.89</a:t>
+                        <a:t>$26.84</a:t>
                       </a:r>
                     </a:p>
                   </a:txBody>
@@ -7318,7 +7318,7 @@
                           </a:solidFill>
                           <a:latin typeface="Calibri"/>
                         </a:rPr>
-                        <a:t>$29.70</a:t>
+                        <a:t>$29.65</a:t>
                       </a:r>
                     </a:p>
                   </a:txBody>
@@ -7341,7 +7341,7 @@
                           </a:solidFill>
                           <a:latin typeface="Calibri"/>
                         </a:rPr>
-                        <a:t>$32.51</a:t>
+                        <a:t>$32.47</a:t>
                       </a:r>
                     </a:p>
                   </a:txBody>
@@ -7364,7 +7364,7 @@
                           </a:solidFill>
                           <a:latin typeface="Calibri"/>
                         </a:rPr>
-                        <a:t>$35.33</a:t>
+                        <a:t>$35.28</a:t>
                       </a:r>
                     </a:p>
                   </a:txBody>
@@ -7387,7 +7387,7 @@
                           </a:solidFill>
                           <a:latin typeface="Calibri"/>
                         </a:rPr>
-                        <a:t>$38.14</a:t>
+                        <a:t>$38.09</a:t>
                       </a:r>
                     </a:p>
                   </a:txBody>
@@ -7412,7 +7412,7 @@
                           </a:solidFill>
                           <a:latin typeface="Calibri"/>
                         </a:rPr>
-                        <a:t>9.70%</a:t>
+                        <a:t>9.72%</a:t>
                       </a:r>
                     </a:p>
                   </a:txBody>
@@ -7435,7 +7435,7 @@
                           </a:solidFill>
                           <a:latin typeface="Calibri"/>
                         </a:rPr>
-                        <a:t>$26.38</a:t>
+                        <a:t>$26.33</a:t>
                       </a:r>
                     </a:p>
                   </a:txBody>
@@ -7458,7 +7458,7 @@
                           </a:solidFill>
                           <a:latin typeface="Calibri"/>
                         </a:rPr>
-                        <a:t>$29.13</a:t>
+                        <a:t>$29.08</a:t>
                       </a:r>
                     </a:p>
                   </a:txBody>
@@ -7481,7 +7481,7 @@
                           </a:solidFill>
                           <a:latin typeface="Calibri"/>
                         </a:rPr>
-                        <a:t>$31.87</a:t>
+                        <a:t>$31.83</a:t>
                       </a:r>
                     </a:p>
                   </a:txBody>
@@ -7504,7 +7504,7 @@
                           </a:solidFill>
                           <a:latin typeface="Calibri"/>
                         </a:rPr>
-                        <a:t>$34.62</a:t>
+                        <a:t>$34.57</a:t>
                       </a:r>
                     </a:p>
                   </a:txBody>
@@ -7527,7 +7527,7 @@
                           </a:solidFill>
                           <a:latin typeface="Calibri"/>
                         </a:rPr>
-                        <a:t>$37.37</a:t>
+                        <a:t>$37.32</a:t>
                       </a:r>
                     </a:p>
                   </a:txBody>
@@ -7552,7 +7552,7 @@
                           </a:solidFill>
                           <a:latin typeface="Calibri"/>
                         </a:rPr>
-                        <a:t>10.20%</a:t>
+                        <a:t>10.22%</a:t>
                       </a:r>
                     </a:p>
                   </a:txBody>
@@ -7575,7 +7575,7 @@
                           </a:solidFill>
                           <a:latin typeface="Calibri"/>
                         </a:rPr>
-                        <a:t>$25.88</a:t>
+                        <a:t>$25.83</a:t>
                       </a:r>
                     </a:p>
                   </a:txBody>
@@ -7598,7 +7598,7 @@
                           </a:solidFill>
                           <a:latin typeface="Calibri"/>
                         </a:rPr>
-                        <a:t>$28.56</a:t>
+                        <a:t>$28.52</a:t>
                       </a:r>
                     </a:p>
                   </a:txBody>
@@ -7621,7 +7621,7 @@
                           </a:solidFill>
                           <a:latin typeface="Calibri"/>
                         </a:rPr>
-                        <a:t>$31.25</a:t>
+                        <a:t>$31.20</a:t>
                       </a:r>
                     </a:p>
                   </a:txBody>
@@ -7644,7 +7644,7 @@
                           </a:solidFill>
                           <a:latin typeface="Calibri"/>
                         </a:rPr>
-                        <a:t>$33.94</a:t>
+                        <a:t>$33.89</a:t>
                       </a:r>
                     </a:p>
                   </a:txBody>
@@ -7667,7 +7667,7 @@
                           </a:solidFill>
                           <a:latin typeface="Calibri"/>
                         </a:rPr>
-                        <a:t>$36.63</a:t>
+                        <a:t>$36.57</a:t>
                       </a:r>
                     </a:p>
                   </a:txBody>
@@ -7747,7 +7747,7 @@
                 </a:solidFill>
                 <a:latin typeface="Calibri"/>
               </a:rPr>
-              <a:t>NKE · 2026-10-05 · 10</a:t>
+              <a:t>NKE · 2026-10-12 · 10</a:t>
             </a:r>
           </a:p>
         </p:txBody>
@@ -7835,7 +7835,7 @@
                 </a:solidFill>
                 <a:latin typeface="Cambria"/>
               </a:rPr>
-              <a:t>Trading comps: NKE trades at 10.7x EV/EBITDA, a 25% premium to the peer median of 8.6x</a:t>
+              <a:t>Trading comps: NKE trades at 11.3x EV/EBITDA, a 32% premium to the peer median of 8.6x</a:t>
             </a:r>
           </a:p>
         </p:txBody>
@@ -8091,7 +8091,7 @@
                           </a:solidFill>
                           <a:latin typeface="Calibri"/>
                         </a:rPr>
-                        <a:t>$10.8bn</a:t>
+                        <a:t>$11.4bn</a:t>
                       </a:r>
                     </a:p>
                   </a:txBody>
@@ -8114,7 +8114,7 @@
                           </a:solidFill>
                           <a:latin typeface="Calibri"/>
                         </a:rPr>
-                        <a:t>$9.2bn</a:t>
+                        <a:t>$9.8bn</a:t>
                       </a:r>
                     </a:p>
                   </a:txBody>
@@ -8137,7 +8137,7 @@
                           </a:solidFill>
                           <a:latin typeface="Calibri"/>
                         </a:rPr>
-                        <a:t>1.7x</a:t>
+                        <a:t>1.8x</a:t>
                       </a:r>
                     </a:p>
                   </a:txBody>
@@ -8160,7 +8160,7 @@
                           </a:solidFill>
                           <a:latin typeface="Calibri"/>
                         </a:rPr>
-                        <a:t>6.9x</a:t>
+                        <a:t>7.3x</a:t>
                       </a:r>
                     </a:p>
                   </a:txBody>
@@ -8183,7 +8183,7 @@
                           </a:solidFill>
                           <a:latin typeface="Calibri"/>
                         </a:rPr>
-                        <a:t>10.6x</a:t>
+                        <a:t>11.1x</a:t>
                       </a:r>
                     </a:p>
                   </a:txBody>
@@ -8229,7 +8229,7 @@
                           </a:solidFill>
                           <a:latin typeface="Calibri"/>
                         </a:rPr>
-                        <a:t>10.1%</a:t>
+                        <a:t>9.6%</a:t>
                       </a:r>
                     </a:p>
                   </a:txBody>
@@ -8277,7 +8277,7 @@
                           </a:solidFill>
                           <a:latin typeface="Calibri"/>
                         </a:rPr>
-                        <a:t>$9.7bn</a:t>
+                        <a:t>$10.0bn</a:t>
                       </a:r>
                     </a:p>
                   </a:txBody>
@@ -8300,7 +8300,7 @@
                           </a:solidFill>
                           <a:latin typeface="Calibri"/>
                         </a:rPr>
-                        <a:t>$8.3bn</a:t>
+                        <a:t>$8.6bn</a:t>
                       </a:r>
                     </a:p>
                   </a:txBody>
@@ -8323,7 +8323,7 @@
                           </a:solidFill>
                           <a:latin typeface="Calibri"/>
                         </a:rPr>
-                        <a:t>0.7x</a:t>
+                        <a:t>0.8x</a:t>
                       </a:r>
                     </a:p>
                   </a:txBody>
@@ -8346,7 +8346,7 @@
                           </a:solidFill>
                           <a:latin typeface="Calibri"/>
                         </a:rPr>
-                        <a:t>3.1x</a:t>
+                        <a:t>3.2x</a:t>
                       </a:r>
                     </a:p>
                   </a:txBody>
@@ -8369,7 +8369,7 @@
                           </a:solidFill>
                           <a:latin typeface="Calibri"/>
                         </a:rPr>
-                        <a:t>6.1x</a:t>
+                        <a:t>6.3x</a:t>
                       </a:r>
                     </a:p>
                   </a:txBody>
@@ -8415,7 +8415,7 @@
                           </a:solidFill>
                           <a:latin typeface="Calibri"/>
                         </a:rPr>
-                        <a:t>9.5%</a:t>
+                        <a:t>9.3%</a:t>
                       </a:r>
                     </a:p>
                   </a:txBody>
@@ -8440,7 +8440,7 @@
                           </a:solidFill>
                           <a:latin typeface="Calibri"/>
                         </a:rPr>
-                        <a:t>CROX · Crocs</a:t>
+                        <a:t>VFC · VF</a:t>
                       </a:r>
                     </a:p>
                   </a:txBody>
@@ -8463,7 +8463,7 @@
                           </a:solidFill>
                           <a:latin typeface="Calibri"/>
                         </a:rPr>
-                        <a:t>$5.7bn</a:t>
+                        <a:t>$6.2bn</a:t>
                       </a:r>
                     </a:p>
                   </a:txBody>
@@ -8486,7 +8486,7 @@
                           </a:solidFill>
                           <a:latin typeface="Calibri"/>
                         </a:rPr>
-                        <a:t>$6.8bn</a:t>
+                        <a:t>$8.9bn</a:t>
                       </a:r>
                     </a:p>
                   </a:txBody>
@@ -8509,7 +8509,7 @@
                           </a:solidFill>
                           <a:latin typeface="Calibri"/>
                         </a:rPr>
-                        <a:t>1.7x</a:t>
+                        <a:t>0.9x</a:t>
                       </a:r>
                     </a:p>
                   </a:txBody>
@@ -8532,7 +8532,7 @@
                           </a:solidFill>
                           <a:latin typeface="Calibri"/>
                         </a:rPr>
-                        <a:t>29.9x</a:t>
+                        <a:t>10.4x</a:t>
                       </a:r>
                     </a:p>
                   </a:txBody>
@@ -8555,7 +8555,7 @@
                           </a:solidFill>
                           <a:latin typeface="Calibri"/>
                         </a:rPr>
-                        <a:t>n/a</a:t>
+                        <a:t>24.2x</a:t>
                       </a:r>
                     </a:p>
                   </a:txBody>
@@ -8578,7 +8578,7 @@
                           </a:solidFill>
                           <a:latin typeface="Calibri"/>
                         </a:rPr>
-                        <a:t>3.7%</a:t>
+                        <a:t>6.0%</a:t>
                       </a:r>
                     </a:p>
                   </a:txBody>
@@ -8601,7 +8601,7 @@
                           </a:solidFill>
                           <a:latin typeface="Calibri"/>
                         </a:rPr>
-                        <a:t>11.6%</a:t>
+                        <a:t>9.0%</a:t>
                       </a:r>
                     </a:p>
                   </a:txBody>
@@ -8626,7 +8626,7 @@
                           </a:solidFill>
                           <a:latin typeface="Calibri"/>
                         </a:rPr>
-                        <a:t>VFC · VF</a:t>
+                        <a:t>CROX · Crocs</a:t>
                       </a:r>
                     </a:p>
                   </a:txBody>
@@ -8649,7 +8649,7 @@
                           </a:solidFill>
                           <a:latin typeface="Calibri"/>
                         </a:rPr>
-                        <a:t>$5.5bn</a:t>
+                        <a:t>$5.7bn</a:t>
                       </a:r>
                     </a:p>
                   </a:txBody>
@@ -8672,7 +8672,7 @@
                           </a:solidFill>
                           <a:latin typeface="Calibri"/>
                         </a:rPr>
-                        <a:t>$8.2bn</a:t>
+                        <a:t>$6.8bn</a:t>
                       </a:r>
                     </a:p>
                   </a:txBody>
@@ -8695,7 +8695,7 @@
                           </a:solidFill>
                           <a:latin typeface="Calibri"/>
                         </a:rPr>
-                        <a:t>0.9x</a:t>
+                        <a:t>1.7x</a:t>
                       </a:r>
                     </a:p>
                   </a:txBody>
@@ -8718,7 +8718,7 @@
                           </a:solidFill>
                           <a:latin typeface="Calibri"/>
                         </a:rPr>
-                        <a:t>9.6x</a:t>
+                        <a:t>29.8x</a:t>
                       </a:r>
                     </a:p>
                   </a:txBody>
@@ -8741,7 +8741,7 @@
                           </a:solidFill>
                           <a:latin typeface="Calibri"/>
                         </a:rPr>
-                        <a:t>21.7x</a:t>
+                        <a:t>n/a</a:t>
                       </a:r>
                     </a:p>
                   </a:txBody>
@@ -8764,7 +8764,7 @@
                           </a:solidFill>
                           <a:latin typeface="Calibri"/>
                         </a:rPr>
-                        <a:t>6.0%</a:t>
+                        <a:t>3.7%</a:t>
                       </a:r>
                     </a:p>
                   </a:txBody>
@@ -8787,7 +8787,7 @@
                           </a:solidFill>
                           <a:latin typeface="Calibri"/>
                         </a:rPr>
-                        <a:t>10.1%</a:t>
+                        <a:t>11.7%</a:t>
                       </a:r>
                     </a:p>
                   </a:txBody>
@@ -9021,7 +9021,7 @@
                           </a:solidFill>
                           <a:latin typeface="Calibri"/>
                         </a:rPr>
-                        <a:t>$2.0bn</a:t>
+                        <a:t>$2.1bn</a:t>
                       </a:r>
                     </a:p>
                   </a:txBody>
@@ -9044,7 +9044,7 @@
                           </a:solidFill>
                           <a:latin typeface="Calibri"/>
                         </a:rPr>
-                        <a:t>$2.2bn</a:t>
+                        <a:t>$2.3bn</a:t>
                       </a:r>
                     </a:p>
                   </a:txBody>
@@ -9067,7 +9067,7 @@
                           </a:solidFill>
                           <a:latin typeface="Calibri"/>
                         </a:rPr>
-                        <a:t>0.4x</a:t>
+                        <a:t>0.5x</a:t>
                       </a:r>
                     </a:p>
                   </a:txBody>
@@ -9159,7 +9159,7 @@
                           </a:solidFill>
                           <a:latin typeface="Calibri"/>
                         </a:rPr>
-                        <a:t>-8.2%</a:t>
+                        <a:t>-7.6%</a:t>
                       </a:r>
                     </a:p>
                   </a:txBody>
@@ -9207,7 +9207,7 @@
                           </a:solidFill>
                           <a:latin typeface="Calibri"/>
                         </a:rPr>
-                        <a:t>$49.1bn</a:t>
+                        <a:t>$52.0bn</a:t>
                       </a:r>
                     </a:p>
                   </a:txBody>
@@ -9230,7 +9230,7 @@
                           </a:solidFill>
                           <a:latin typeface="Calibri"/>
                         </a:rPr>
-                        <a:t>$48.7bn</a:t>
+                        <a:t>$51.6bn</a:t>
                       </a:r>
                     </a:p>
                   </a:txBody>
@@ -9253,7 +9253,7 @@
                           </a:solidFill>
                           <a:latin typeface="Calibri"/>
                         </a:rPr>
-                        <a:t>1.0x</a:t>
+                        <a:t>1.1x</a:t>
                       </a:r>
                     </a:p>
                   </a:txBody>
@@ -9276,7 +9276,7 @@
                           </a:solidFill>
                           <a:latin typeface="Calibri"/>
                         </a:rPr>
-                        <a:t>10.7x</a:t>
+                        <a:t>11.3x</a:t>
                       </a:r>
                     </a:p>
                   </a:txBody>
@@ -9299,7 +9299,7 @@
                           </a:solidFill>
                           <a:latin typeface="Calibri"/>
                         </a:rPr>
-                        <a:t>15.8x</a:t>
+                        <a:t>16.7x</a:t>
                       </a:r>
                     </a:p>
                   </a:txBody>
@@ -9345,7 +9345,7 @@
                           </a:solidFill>
                           <a:latin typeface="Calibri"/>
                         </a:rPr>
-                        <a:t>4.4%</a:t>
+                        <a:t>4.2%</a:t>
                       </a:r>
                     </a:p>
                   </a:txBody>
@@ -9485,7 +9485,7 @@
                           </a:solidFill>
                           <a:latin typeface="Calibri"/>
                         </a:rPr>
-                        <a:t>13.4x</a:t>
+                        <a:t>13.7x</a:t>
                       </a:r>
                     </a:p>
                   </a:txBody>
@@ -9531,7 +9531,7 @@
                           </a:solidFill>
                           <a:latin typeface="Calibri"/>
                         </a:rPr>
-                        <a:t>9.8%</a:t>
+                        <a:t>9.1%</a:t>
                       </a:r>
                     </a:p>
                   </a:txBody>
@@ -9585,7 +9585,7 @@
                 </a:solidFill>
                 <a:latin typeface="Calibri"/>
               </a:rPr>
-              <a:t>EV/EBITDA: $26.57 (range $21.41–$29.74) · P/E: $28.12 (range $19.81–$36.94)</a:t>
+              <a:t>EV/EBITDA: $26.54 (range $22.72–$32.05) · P/E: $28.69 (range $20.78–$38.25)</a:t>
             </a:r>
           </a:p>
         </p:txBody>
@@ -9655,7 +9655,7 @@
                 </a:solidFill>
                 <a:latin typeface="Calibri"/>
               </a:rPr>
-              <a:t>NKE · 2026-10-05 · 11</a:t>
+              <a:t>NKE · 2026-10-12 · 11</a:t>
             </a:r>
           </a:p>
         </p:txBody>
@@ -9743,7 +9743,7 @@
                 </a:solidFill>
                 <a:latin typeface="Cambria"/>
               </a:rPr>
-              <a:t>Valuation range: methods point to $20–$71; price target $32.56</a:t>
+              <a:t>Valuation range: methods point to $21–$70; price target $32.49</a:t>
             </a:r>
           </a:p>
         </p:txBody>
@@ -9778,7 +9778,7 @@
                 </a:solidFill>
                 <a:latin typeface="Calibri"/>
               </a:rPr>
-              <a:t>$18</a:t>
+              <a:t>$19</a:t>
             </a:r>
           </a:p>
         </p:txBody>
@@ -9813,7 +9813,7 @@
                 </a:solidFill>
                 <a:latin typeface="Calibri"/>
               </a:rPr>
-              <a:t>$29</a:t>
+              <a:t>$30</a:t>
             </a:r>
           </a:p>
         </p:txBody>
@@ -9848,7 +9848,7 @@
                 </a:solidFill>
                 <a:latin typeface="Calibri"/>
               </a:rPr>
-              <a:t>$41</a:t>
+              <a:t>$40</a:t>
             </a:r>
           </a:p>
         </p:txBody>
@@ -9861,7 +9861,7 @@
         </p:nvSpPr>
         <p:spPr>
           <a:xfrm>
-            <a:off x="8028431" y="5504688"/>
+            <a:off x="8028432" y="5504688"/>
             <a:ext cx="914400" cy="274320"/>
           </a:xfrm>
           <a:prstGeom prst="rect">
@@ -9883,7 +9883,7 @@
                 </a:solidFill>
                 <a:latin typeface="Calibri"/>
               </a:rPr>
-              <a:t>$52</a:t>
+              <a:t>$51</a:t>
             </a:r>
           </a:p>
         </p:txBody>
@@ -9918,7 +9918,7 @@
                 </a:solidFill>
                 <a:latin typeface="Calibri"/>
               </a:rPr>
-              <a:t>$63</a:t>
+              <a:t>$62</a:t>
             </a:r>
           </a:p>
         </p:txBody>
@@ -9953,7 +9953,7 @@
                 </a:solidFill>
                 <a:latin typeface="Calibri"/>
               </a:rPr>
-              <a:t>$75</a:t>
+              <a:t>$73</a:t>
             </a:r>
           </a:p>
         </p:txBody>
@@ -10001,8 +10001,8 @@
         </p:nvSpPr>
         <p:spPr>
           <a:xfrm>
-            <a:off x="6122418" y="2167128"/>
-            <a:ext cx="4770093" cy="347472"/>
+            <a:off x="6192868" y="2167128"/>
+            <a:ext cx="4689449" cy="347472"/>
           </a:xfrm>
           <a:prstGeom prst="rect">
             <a:avLst/>
@@ -10045,7 +10045,7 @@
         </p:nvSpPr>
         <p:spPr>
           <a:xfrm>
-            <a:off x="5253738" y="2212848"/>
+            <a:off x="5324188" y="2212848"/>
             <a:ext cx="822960" cy="274320"/>
           </a:xfrm>
           <a:prstGeom prst="rect">
@@ -10067,7 +10067,7 @@
                 </a:solidFill>
                 <a:latin typeface="Calibri"/>
               </a:rPr>
-              <a:t>$33</a:t>
+              <a:t>$34</a:t>
             </a:r>
           </a:p>
         </p:txBody>
@@ -10080,7 +10080,7 @@
         </p:nvSpPr>
         <p:spPr>
           <a:xfrm>
-            <a:off x="10938231" y="2212848"/>
+            <a:off x="10928037" y="2212848"/>
             <a:ext cx="822960" cy="274320"/>
           </a:xfrm>
           <a:prstGeom prst="rect">
@@ -10102,7 +10102,7 @@
                 </a:solidFill>
                 <a:latin typeface="Calibri"/>
               </a:rPr>
-              <a:t>$71</a:t>
+              <a:t>$70</a:t>
             </a:r>
           </a:p>
         </p:txBody>
@@ -10137,7 +10137,7 @@
                 </a:solidFill>
                 <a:latin typeface="Calibri"/>
               </a:rPr>
-              <a:t>Trading comps: EV/EBITDA 6.9x–9.6x</a:t>
+              <a:t>Trading comps: EV/EBITDA 7.3x–10.4x</a:t>
             </a:r>
           </a:p>
         </p:txBody>
@@ -10150,8 +10150,8 @@
         </p:nvSpPr>
         <p:spPr>
           <a:xfrm>
-            <a:off x="4655117" y="2734056"/>
-            <a:ext cx="1044118" cy="347472"/>
+            <a:off x="4732357" y="2734056"/>
+            <a:ext cx="1221908" cy="347472"/>
           </a:xfrm>
           <a:prstGeom prst="rect">
             <a:avLst/>
@@ -10194,7 +10194,7 @@
         </p:nvSpPr>
         <p:spPr>
           <a:xfrm>
-            <a:off x="3786437" y="2779776"/>
+            <a:off x="3863677" y="2779776"/>
             <a:ext cx="822960" cy="274320"/>
           </a:xfrm>
           <a:prstGeom prst="rect">
@@ -10216,7 +10216,7 @@
                 </a:solidFill>
                 <a:latin typeface="Calibri"/>
               </a:rPr>
-              <a:t>$21</a:t>
+              <a:t>$23</a:t>
             </a:r>
           </a:p>
         </p:txBody>
@@ -10229,7 +10229,7 @@
         </p:nvSpPr>
         <p:spPr>
           <a:xfrm>
-            <a:off x="5744955" y="2779776"/>
+            <a:off x="5999985" y="2779776"/>
             <a:ext cx="822960" cy="274320"/>
           </a:xfrm>
           <a:prstGeom prst="rect">
@@ -10251,7 +10251,7 @@
                 </a:solidFill>
                 <a:latin typeface="Calibri"/>
               </a:rPr>
-              <a:t>$30</a:t>
+              <a:t>$32</a:t>
             </a:r>
           </a:p>
         </p:txBody>
@@ -10286,7 +10286,7 @@
                 </a:solidFill>
                 <a:latin typeface="Calibri"/>
               </a:rPr>
-              <a:t>Trading comps: P/E 9.5x–17.6x</a:t>
+              <a:t>Trading comps: P/E 9.9x–18.3x</a:t>
             </a:r>
           </a:p>
         </p:txBody>
@@ -10299,8 +10299,8 @@
         </p:nvSpPr>
         <p:spPr>
           <a:xfrm>
-            <a:off x="4454539" y="3300984"/>
-            <a:ext cx="2147738" cy="347472"/>
+            <a:off x="4478325" y="3300984"/>
+            <a:ext cx="2287868" cy="347472"/>
           </a:xfrm>
           <a:prstGeom prst="rect">
             <a:avLst/>
@@ -10343,7 +10343,7 @@
         </p:nvSpPr>
         <p:spPr>
           <a:xfrm>
-            <a:off x="3585859" y="3346704"/>
+            <a:off x="3609645" y="3346704"/>
             <a:ext cx="822960" cy="274320"/>
           </a:xfrm>
           <a:prstGeom prst="rect">
@@ -10365,7 +10365,7 @@
                 </a:solidFill>
                 <a:latin typeface="Calibri"/>
               </a:rPr>
-              <a:t>$20</a:t>
+              <a:t>$21</a:t>
             </a:r>
           </a:p>
         </p:txBody>
@@ -10378,7 +10378,7 @@
         </p:nvSpPr>
         <p:spPr>
           <a:xfrm>
-            <a:off x="6647998" y="3346704"/>
+            <a:off x="6811913" y="3346704"/>
             <a:ext cx="822960" cy="274320"/>
           </a:xfrm>
           <a:prstGeom prst="rect">
@@ -10400,7 +10400,7 @@
                 </a:solidFill>
                 <a:latin typeface="Calibri"/>
               </a:rPr>
-              <a:t>$37</a:t>
+              <a:t>$38</a:t>
             </a:r>
           </a:p>
         </p:txBody>
@@ -10448,8 +10448,8 @@
         </p:nvSpPr>
         <p:spPr>
           <a:xfrm>
-            <a:off x="5998705" y="3867911"/>
-            <a:ext cx="971133" cy="347472"/>
+            <a:off x="5954632" y="3867911"/>
+            <a:ext cx="1009055" cy="347472"/>
           </a:xfrm>
           <a:prstGeom prst="rect">
             <a:avLst/>
@@ -10492,7 +10492,7 @@
         </p:nvSpPr>
         <p:spPr>
           <a:xfrm>
-            <a:off x="5130025" y="3913631"/>
+            <a:off x="5085952" y="3913631"/>
             <a:ext cx="822960" cy="274320"/>
           </a:xfrm>
           <a:prstGeom prst="rect">
@@ -10527,7 +10527,7 @@
         </p:nvSpPr>
         <p:spPr>
           <a:xfrm>
-            <a:off x="7015558" y="3913631"/>
+            <a:off x="7009407" y="3913631"/>
             <a:ext cx="822960" cy="274320"/>
           </a:xfrm>
           <a:prstGeom prst="rect">
@@ -10597,8 +10597,8 @@
         </p:nvSpPr>
         <p:spPr>
           <a:xfrm>
-            <a:off x="5622334" y="4434840"/>
-            <a:ext cx="868026" cy="347472"/>
+            <a:off x="5565477" y="4434840"/>
+            <a:ext cx="905946" cy="347472"/>
           </a:xfrm>
           <a:prstGeom prst="rect">
             <a:avLst/>
@@ -10641,7 +10641,7 @@
         </p:nvSpPr>
         <p:spPr>
           <a:xfrm>
-            <a:off x="4753654" y="4480560"/>
+            <a:off x="4696797" y="4480560"/>
             <a:ext cx="822960" cy="274320"/>
           </a:xfrm>
           <a:prstGeom prst="rect">
@@ -10676,7 +10676,7 @@
         </p:nvSpPr>
         <p:spPr>
           <a:xfrm>
-            <a:off x="6536081" y="4480560"/>
+            <a:off x="6517144" y="4480560"/>
             <a:ext cx="822960" cy="274320"/>
           </a:xfrm>
           <a:prstGeom prst="rect">
@@ -10746,8 +10746,8 @@
         </p:nvSpPr>
         <p:spPr>
           <a:xfrm>
-            <a:off x="4792027" y="5001768"/>
-            <a:ext cx="4515570" cy="347472"/>
+            <a:off x="4697712" y="5001768"/>
+            <a:ext cx="4697593" cy="347472"/>
           </a:xfrm>
           <a:prstGeom prst="rect">
             <a:avLst/>
@@ -10790,7 +10790,7 @@
         </p:nvSpPr>
         <p:spPr>
           <a:xfrm>
-            <a:off x="3923347" y="5047488"/>
+            <a:off x="3829032" y="5047488"/>
             <a:ext cx="822960" cy="274320"/>
           </a:xfrm>
           <a:prstGeom prst="rect">
@@ -10812,7 +10812,7 @@
                 </a:solidFill>
                 <a:latin typeface="Calibri"/>
               </a:rPr>
-              <a:t>$23</a:t>
+              <a:t>$22</a:t>
             </a:r>
           </a:p>
         </p:txBody>
@@ -10825,7 +10825,7 @@
         </p:nvSpPr>
         <p:spPr>
           <a:xfrm>
-            <a:off x="9353318" y="5047488"/>
+            <a:off x="9441025" y="5047488"/>
             <a:ext cx="822960" cy="274320"/>
           </a:xfrm>
           <a:prstGeom prst="rect">
@@ -10847,7 +10847,7 @@
                 </a:solidFill>
                 <a:latin typeface="Calibri"/>
               </a:rPr>
-              <a:t>$59</a:t>
+              <a:t>$58</a:t>
             </a:r>
           </a:p>
         </p:txBody>
@@ -10860,7 +10860,7 @@
         </p:nvCxnSpPr>
         <p:spPr>
           <a:xfrm>
-            <a:off x="6122418" y="1965960"/>
+            <a:off x="6348048" y="1965960"/>
             <a:ext cx="0" cy="3493008"/>
           </a:xfrm>
           <a:prstGeom prst="line">
@@ -10896,7 +10896,7 @@
         </p:nvCxnSpPr>
         <p:spPr>
           <a:xfrm>
-            <a:off x="6052351" y="1965960"/>
+            <a:off x="6011986" y="1965960"/>
             <a:ext cx="0" cy="3493008"/>
           </a:xfrm>
           <a:prstGeom prst="line">
@@ -10931,7 +10931,7 @@
         </p:nvSpPr>
         <p:spPr>
           <a:xfrm>
-            <a:off x="6195570" y="1673352"/>
+            <a:off x="6421200" y="1673352"/>
             <a:ext cx="1828800" cy="274320"/>
           </a:xfrm>
           <a:prstGeom prst="rect">
@@ -10953,7 +10953,7 @@
                 </a:solidFill>
                 <a:latin typeface="Calibri"/>
               </a:rPr>
-              <a:t>Price $33.12</a:t>
+              <a:t>Price $35.06</a:t>
             </a:r>
           </a:p>
         </p:txBody>
@@ -10966,7 +10966,7 @@
         </p:nvSpPr>
         <p:spPr>
           <a:xfrm>
-            <a:off x="4150399" y="1673352"/>
+            <a:off x="4110034" y="1673352"/>
             <a:ext cx="1828800" cy="274320"/>
           </a:xfrm>
           <a:prstGeom prst="rect">
@@ -10988,7 +10988,7 @@
                 </a:solidFill>
                 <a:latin typeface="Calibri"/>
               </a:rPr>
-              <a:t>Target $32.56</a:t>
+              <a:t>Target $32.49</a:t>
             </a:r>
           </a:p>
         </p:txBody>
@@ -11023,7 +11023,7 @@
                 </a:solidFill>
                 <a:latin typeface="Calibri"/>
               </a:rPr>
-              <a:t>Price target = 50% × DCF perpetuity ($35.57) + 25% × DCF exit multiple ($32.51) + 25% × comps EV/EBITDA ($26.57)</a:t>
+              <a:t>Price target = 50% × DCF perpetuity ($35.47) + 25% × DCF exit multiple ($32.47) + 25% × comps EV/EBITDA ($26.54)</a:t>
             </a:r>
           </a:p>
         </p:txBody>
@@ -11093,7 +11093,7 @@
                 </a:solidFill>
                 <a:latin typeface="Calibri"/>
               </a:rPr>
-              <a:t>NKE · 2026-10-05 · 12</a:t>
+              <a:t>NKE · 2026-10-12 · 12</a:t>
             </a:r>
           </a:p>
         </p:txBody>
@@ -11181,7 +11181,7 @@
                 </a:solidFill>
                 <a:latin typeface="Cambria"/>
               </a:rPr>
-              <a:t>Scenarios: $23 bear, $36 base, $59 bull (DCF value per share)</a:t>
+              <a:t>Scenarios: $22 bear, $35 base, $58 bull (DCF value per share)</a:t>
             </a:r>
           </a:p>
         </p:txBody>
@@ -11295,7 +11295,7 @@
                 </a:solidFill>
                 <a:latin typeface="Cambria"/>
               </a:rPr>
-              <a:t>$22.50</a:t>
+              <a:t>$22.45</a:t>
             </a:r>
           </a:p>
         </p:txBody>
@@ -11330,7 +11330,7 @@
                 </a:solidFill>
                 <a:latin typeface="Calibri"/>
               </a:rPr>
-              <a:t>-32% vs current price</a:t>
+              <a:t>-36% vs current price</a:t>
             </a:r>
           </a:p>
         </p:txBody>
@@ -11724,7 +11724,7 @@
                 </a:solidFill>
                 <a:latin typeface="Cambria"/>
               </a:rPr>
-              <a:t>$35.57</a:t>
+              <a:t>$35.47</a:t>
             </a:r>
           </a:p>
         </p:txBody>
@@ -11759,7 +11759,7 @@
                 </a:solidFill>
                 <a:latin typeface="Calibri"/>
               </a:rPr>
-              <a:t>+7% vs current price</a:t>
+              <a:t>+1% vs current price</a:t>
             </a:r>
           </a:p>
         </p:txBody>
@@ -12153,7 +12153,7 @@
                 </a:solidFill>
                 <a:latin typeface="Cambria"/>
               </a:rPr>
-              <a:t>$58.53</a:t>
+              <a:t>$58.32</a:t>
             </a:r>
           </a:p>
         </p:txBody>
@@ -12188,7 +12188,7 @@
                 </a:solidFill>
                 <a:latin typeface="Calibri"/>
               </a:rPr>
-              <a:t>+77% vs current price</a:t>
+              <a:t>+66% vs current price</a:t>
             </a:r>
           </a:p>
         </p:txBody>
@@ -12538,7 +12538,7 @@
                 </a:solidFill>
                 <a:latin typeface="Calibri"/>
               </a:rPr>
-              <a:t>NKE · 2026-10-05 · 13</a:t>
+              <a:t>NKE · 2026-10-12 · 13</a:t>
             </a:r>
           </a:p>
         </p:txBody>
@@ -12759,7 +12759,7 @@
                 </a:solidFill>
                 <a:latin typeface="Calibri"/>
               </a:rPr>
-              <a:t>Premium multiple (10.7x EV/EBITDA vs peers 8.6x) despite below-median growth.</a:t>
+              <a:t>Premium multiple (11.3x EV/EBITDA vs peers 8.6x) despite below-median growth.</a:t>
             </a:r>
           </a:p>
         </p:txBody>
@@ -13095,7 +13095,7 @@
                 </a:solidFill>
                 <a:latin typeface="Calibri"/>
               </a:rPr>
-              <a:t>NKE · 2026-10-05 · 14</a:t>
+              <a:t>NKE · 2026-10-12 · 14</a:t>
             </a:r>
           </a:p>
         </p:txBody>
@@ -13515,7 +13515,7 @@
                 </a:solidFill>
                 <a:latin typeface="Calibri"/>
               </a:rPr>
-              <a:t>NKE · 2026-10-05 · 15</a:t>
+              <a:t>NKE · 2026-10-12 · 15</a:t>
             </a:r>
           </a:p>
         </p:txBody>
@@ -13603,7 +13603,7 @@
                 </a:solidFill>
                 <a:latin typeface="Cambria"/>
               </a:rPr>
-              <a:t>HOLD: $32.56 price target implies 2% downside</a:t>
+              <a:t>HOLD: $32.49 price target implies 7% downside</a:t>
             </a:r>
           </a:p>
         </p:txBody>
@@ -13831,7 +13831,7 @@
                 </a:solidFill>
                 <a:latin typeface="Cambria"/>
               </a:rPr>
-              <a:t>$32.56</a:t>
+              <a:t>$32.49</a:t>
             </a:r>
           </a:p>
         </p:txBody>
@@ -13945,7 +13945,7 @@
                 </a:solidFill>
                 <a:latin typeface="Cambria"/>
               </a:rPr>
-              <a:t>-1.7%</a:t>
+              <a:t>-7.3%</a:t>
             </a:r>
           </a:p>
         </p:txBody>
@@ -14166,7 +14166,7 @@
                 </a:solidFill>
                 <a:latin typeface="Calibri"/>
               </a:rPr>
-              <a:t>Price target $32.56 vs $33.12 current: -1.7% implied return → HOLD. DCF (perpetuity growth 2.5%, WACC 9.2%): $35.57 per share; exit-multiple method (8.6x EBITDA): $32.51.</a:t>
+              <a:t>Price target $32.49 vs $35.06 current: -7.3% implied return → HOLD. DCF (perpetuity growth 2.5%, WACC 9.2%): $35.47 per share; exit-multiple method (8.6x EBITDA): $32.47.</a:t>
             </a:r>
           </a:p>
         </p:txBody>
@@ -14236,7 +14236,7 @@
                 </a:solidFill>
                 <a:latin typeface="Calibri"/>
               </a:rPr>
-              <a:t>NKE · 2026-10-05 · 2</a:t>
+              <a:t>NKE · 2026-10-12 · 2</a:t>
             </a:r>
           </a:p>
         </p:txBody>
@@ -15868,7 +15868,7 @@
                 </a:solidFill>
                 <a:latin typeface="Calibri"/>
               </a:rPr>
-              <a:t>$49.1bn</a:t>
+              <a:t>$52.0bn</a:t>
             </a:r>
           </a:p>
         </p:txBody>
@@ -15938,7 +15938,7 @@
                 </a:solidFill>
                 <a:latin typeface="Calibri"/>
               </a:rPr>
-              <a:t>$48.7bn</a:t>
+              <a:t>$51.6bn</a:t>
             </a:r>
           </a:p>
         </p:txBody>
@@ -16078,7 +16078,7 @@
                 </a:solidFill>
                 <a:latin typeface="Calibri"/>
               </a:rPr>
-              <a:t>10.7x</a:t>
+              <a:t>11.3x</a:t>
             </a:r>
           </a:p>
         </p:txBody>
@@ -16148,7 +16148,7 @@
                 </a:solidFill>
                 <a:latin typeface="Calibri"/>
               </a:rPr>
-              <a:t>15.8x</a:t>
+              <a:t>16.7x</a:t>
             </a:r>
           </a:p>
         </p:txBody>
@@ -16218,7 +16218,7 @@
                 </a:solidFill>
                 <a:latin typeface="Calibri"/>
               </a:rPr>
-              <a:t>$33.12 – $71.17</a:t>
+              <a:t>$33.87 – $69.68</a:t>
             </a:r>
           </a:p>
         </p:txBody>
@@ -16428,7 +16428,7 @@
                 </a:solidFill>
                 <a:latin typeface="Calibri"/>
               </a:rPr>
-              <a:t>NKE · 2026-10-05 · 3</a:t>
+              <a:t>NKE · 2026-10-12 · 3</a:t>
             </a:r>
           </a:p>
         </p:txBody>
@@ -16657,7 +16657,7 @@
                 </a:solidFill>
                 <a:latin typeface="Calibri"/>
               </a:rPr>
-              <a:t>NKE · 2026-10-05 · 4</a:t>
+              <a:t>NKE · 2026-10-12 · 4</a:t>
             </a:r>
           </a:p>
         </p:txBody>
@@ -18525,7 +18525,7 @@
                 </a:solidFill>
                 <a:latin typeface="Calibri"/>
               </a:rPr>
-              <a:t>NKE · 2026-10-05 · 5</a:t>
+              <a:t>NKE · 2026-10-12 · 5</a:t>
             </a:r>
           </a:p>
         </p:txBody>
@@ -18834,7 +18834,7 @@
                 </a:solidFill>
                 <a:latin typeface="Calibri"/>
               </a:rPr>
-              <a:t>NKE · 2026-10-05 · 6</a:t>
+              <a:t>NKE · 2026-10-12 · 6</a:t>
             </a:r>
           </a:p>
         </p:txBody>
@@ -19028,7 +19028,7 @@
                 </a:solidFill>
                 <a:latin typeface="Calibri"/>
               </a:rPr>
-              <a:t>NKE · 2026-10-05 · 7</a:t>
+              <a:t>NKE · 2026-10-12 · 7</a:t>
             </a:r>
           </a:p>
         </p:txBody>
@@ -19116,7 +19116,7 @@
                 </a:solidFill>
                 <a:latin typeface="Cambria"/>
               </a:rPr>
-              <a:t>DCF: $35.57 per share at a 9.2% WACC and 2.5% terminal growth</a:t>
+              <a:t>DCF: $35.47 per share at a 9.2% WACC and 2.5% terminal growth</a:t>
             </a:r>
           </a:p>
         </p:txBody>
@@ -19836,7 +19836,7 @@
                           </a:solidFill>
                           <a:latin typeface="Calibri"/>
                         </a:rPr>
-                        <a:t>11,987</a:t>
+                        <a:t>11,982</a:t>
                       </a:r>
                     </a:p>
                   </a:txBody>
@@ -19884,7 +19884,7 @@
                           </a:solidFill>
                           <a:latin typeface="Calibri"/>
                         </a:rPr>
-                        <a:t>40,328</a:t>
+                        <a:t>40,192</a:t>
                       </a:r>
                     </a:p>
                   </a:txBody>
@@ -19932,7 +19932,7 @@
                           </a:solidFill>
                           <a:latin typeface="Calibri"/>
                         </a:rPr>
-                        <a:t>52,315</a:t>
+                        <a:t>52,174</a:t>
                       </a:r>
                     </a:p>
                   </a:txBody>
@@ -20028,7 +20028,7 @@
                           </a:solidFill>
                           <a:latin typeface="Calibri"/>
                         </a:rPr>
-                        <a:t>52,790</a:t>
+                        <a:t>52,649</a:t>
                       </a:r>
                     </a:p>
                   </a:txBody>
@@ -20124,7 +20124,7 @@
                           </a:solidFill>
                           <a:latin typeface="Calibri"/>
                         </a:rPr>
-                        <a:t>$35.57</a:t>
+                        <a:t>$35.47</a:t>
                       </a:r>
                     </a:p>
                   </a:txBody>
@@ -20172,7 +20172,7 @@
                           </a:solidFill>
                           <a:latin typeface="Calibri"/>
                         </a:rPr>
-                        <a:t>77.1%</a:t>
+                        <a:t>77.0%</a:t>
                       </a:r>
                     </a:p>
                   </a:txBody>
@@ -20220,7 +20220,7 @@
                           </a:solidFill>
                           <a:latin typeface="Calibri"/>
                         </a:rPr>
-                        <a:t>9.7x</a:t>
+                        <a:t>9.6x</a:t>
                       </a:r>
                     </a:p>
                   </a:txBody>
@@ -20268,7 +20268,7 @@
                           </a:solidFill>
                           <a:latin typeface="Calibri"/>
                         </a:rPr>
-                        <a:t>$32.51 at 8.6x</a:t>
+                        <a:t>$32.47 at 8.6x</a:t>
                       </a:r>
                     </a:p>
                   </a:txBody>
@@ -20348,7 +20348,7 @@
                 </a:solidFill>
                 <a:latin typeface="Calibri"/>
               </a:rPr>
-              <a:t>NKE · 2026-10-05 · 8</a:t>
+              <a:t>NKE · 2026-10-12 · 8</a:t>
             </a:r>
           </a:p>
         </p:txBody>
@@ -20595,7 +20595,7 @@
                           </a:solidFill>
                           <a:latin typeface="Calibri"/>
                         </a:rPr>
-                        <a:t>FRED DGS10 (10-year Treasury), 2026-10-01</a:t>
+                        <a:t>FRED DGS10 (10-year Treasury), 2026-10-08</a:t>
                       </a:r>
                     </a:p>
                   </a:txBody>
@@ -20714,7 +20714,7 @@
                           </a:solidFill>
                           <a:latin typeface="Calibri"/>
                         </a:rPr>
-                        <a:t>0.94</a:t>
+                        <a:t>0.95</a:t>
                       </a:r>
                     </a:p>
                   </a:txBody>
@@ -20998,7 +20998,7 @@
                           </a:solidFill>
                           <a:latin typeface="Calibri"/>
                         </a:rPr>
-                        <a:t>86% / 14%</a:t>
+                        <a:t>87% / 13%</a:t>
                       </a:r>
                     </a:p>
                   </a:txBody>
@@ -21190,7 +21190,7 @@
                 </a:solidFill>
                 <a:latin typeface="Calibri"/>
               </a:rPr>
-              <a:t>NKE · 2026-10-05 · 9</a:t>
+              <a:t>NKE · 2026-10-12 · 9</a:t>
             </a:r>
           </a:p>
         </p:txBody>

</xml_diff>